<commit_message>
Add LightGBM, cyber theme, threshold tuning, XGBoost TreeSHAP + sidecar
</commit_message>
<xml_diff>
--- a/PRESENTATION.pptx
+++ b/PRESENTATION.pptx
@@ -1707,7 +1707,7 @@
           <a:p>
             <a:fld id="{5BCAD085-E8A6-8845-BD4E-CB4CCA059FC4}" type="datetimeFigureOut">
               <a:rPr lang="en-US" smtClean="0"/>
-              <a:t>5/11/2026</a:t>
+              <a:t>5/12/2026</a:t>
             </a:fld>
             <a:endParaRPr lang="en-US"/>
           </a:p>
@@ -1875,7 +1875,7 @@
           <a:p>
             <a:fld id="{5BCAD085-E8A6-8845-BD4E-CB4CCA059FC4}" type="datetimeFigureOut">
               <a:rPr lang="en-US" smtClean="0"/>
-              <a:t>5/11/2026</a:t>
+              <a:t>5/12/2026</a:t>
             </a:fld>
             <a:endParaRPr lang="en-US"/>
           </a:p>
@@ -2053,7 +2053,7 @@
           <a:p>
             <a:fld id="{5BCAD085-E8A6-8845-BD4E-CB4CCA059FC4}" type="datetimeFigureOut">
               <a:rPr lang="en-US" smtClean="0"/>
-              <a:t>5/11/2026</a:t>
+              <a:t>5/12/2026</a:t>
             </a:fld>
             <a:endParaRPr lang="en-US"/>
           </a:p>
@@ -2221,7 +2221,7 @@
           <a:p>
             <a:fld id="{5BCAD085-E8A6-8845-BD4E-CB4CCA059FC4}" type="datetimeFigureOut">
               <a:rPr lang="en-US" smtClean="0"/>
-              <a:t>5/11/2026</a:t>
+              <a:t>5/12/2026</a:t>
             </a:fld>
             <a:endParaRPr lang="en-US"/>
           </a:p>
@@ -2466,7 +2466,7 @@
           <a:p>
             <a:fld id="{5BCAD085-E8A6-8845-BD4E-CB4CCA059FC4}" type="datetimeFigureOut">
               <a:rPr lang="en-US" smtClean="0"/>
-              <a:t>5/11/2026</a:t>
+              <a:t>5/12/2026</a:t>
             </a:fld>
             <a:endParaRPr lang="en-US"/>
           </a:p>
@@ -2751,7 +2751,7 @@
           <a:p>
             <a:fld id="{5BCAD085-E8A6-8845-BD4E-CB4CCA059FC4}" type="datetimeFigureOut">
               <a:rPr lang="en-US" smtClean="0"/>
-              <a:t>5/11/2026</a:t>
+              <a:t>5/12/2026</a:t>
             </a:fld>
             <a:endParaRPr lang="en-US"/>
           </a:p>
@@ -3170,7 +3170,7 @@
           <a:p>
             <a:fld id="{5BCAD085-E8A6-8845-BD4E-CB4CCA059FC4}" type="datetimeFigureOut">
               <a:rPr lang="en-US" smtClean="0"/>
-              <a:t>5/11/2026</a:t>
+              <a:t>5/12/2026</a:t>
             </a:fld>
             <a:endParaRPr lang="en-US"/>
           </a:p>
@@ -3287,7 +3287,7 @@
           <a:p>
             <a:fld id="{5BCAD085-E8A6-8845-BD4E-CB4CCA059FC4}" type="datetimeFigureOut">
               <a:rPr lang="en-US" smtClean="0"/>
-              <a:t>5/11/2026</a:t>
+              <a:t>5/12/2026</a:t>
             </a:fld>
             <a:endParaRPr lang="en-US"/>
           </a:p>
@@ -3382,7 +3382,7 @@
           <a:p>
             <a:fld id="{5BCAD085-E8A6-8845-BD4E-CB4CCA059FC4}" type="datetimeFigureOut">
               <a:rPr lang="en-US" smtClean="0"/>
-              <a:t>5/11/2026</a:t>
+              <a:t>5/12/2026</a:t>
             </a:fld>
             <a:endParaRPr lang="en-US"/>
           </a:p>
@@ -3657,7 +3657,7 @@
           <a:p>
             <a:fld id="{5BCAD085-E8A6-8845-BD4E-CB4CCA059FC4}" type="datetimeFigureOut">
               <a:rPr lang="en-US" smtClean="0"/>
-              <a:t>5/11/2026</a:t>
+              <a:t>5/12/2026</a:t>
             </a:fld>
             <a:endParaRPr lang="en-US"/>
           </a:p>
@@ -3909,7 +3909,7 @@
           <a:p>
             <a:fld id="{5BCAD085-E8A6-8845-BD4E-CB4CCA059FC4}" type="datetimeFigureOut">
               <a:rPr lang="en-US" smtClean="0"/>
-              <a:t>5/11/2026</a:t>
+              <a:t>5/12/2026</a:t>
             </a:fld>
             <a:endParaRPr lang="en-US"/>
           </a:p>
@@ -4120,7 +4120,7 @@
           <a:p>
             <a:fld id="{5BCAD085-E8A6-8845-BD4E-CB4CCA059FC4}" type="datetimeFigureOut">
               <a:rPr lang="en-US" smtClean="0"/>
-              <a:t>5/11/2026</a:t>
+              <a:t>5/12/2026</a:t>
             </a:fld>
             <a:endParaRPr lang="en-US"/>
           </a:p>
@@ -4953,7 +4953,7 @@
         <p:spPr>
           <a:xfrm>
             <a:off x="640080" y="4297680"/>
-            <a:ext cx="10972800" cy="2468880"/>
+            <a:ext cx="10972800" cy="2518638"/>
           </a:xfrm>
           <a:prstGeom prst="rect">
             <a:avLst/>
@@ -4972,13 +4972,18 @@
               </a:spcAft>
             </a:pPr>
             <a:r>
-              <a:rPr sz="1400">
+              <a:rPr sz="1400" dirty="0">
                 <a:solidFill>
                   <a:srgbClr val="1A1A1A"/>
                 </a:solidFill>
               </a:rPr>
-              <a:t>ROC AUC of 0.82 is the headline:  given a positive + negative pair,</a:t>
-            </a:r>
+              <a:t>ROC AUC of 0.82:</a:t>
+            </a:r>
+            <a:endParaRPr lang="en-US" sz="1400" dirty="0">
+              <a:solidFill>
+                <a:srgbClr val="1A1A1A"/>
+              </a:solidFill>
+            </a:endParaRPr>
           </a:p>
           <a:p>
             <a:pPr>
@@ -4987,12 +4992,20 @@
               </a:spcAft>
             </a:pPr>
             <a:r>
-              <a:rPr sz="1400">
+              <a:rPr lang="en-US" sz="1400" dirty="0">
                 <a:solidFill>
                   <a:srgbClr val="1A1A1A"/>
                 </a:solidFill>
               </a:rPr>
-              <a:t>the model ranks the positive higher 82 % of the time.</a:t>
+              <a:t>G</a:t>
+            </a:r>
+            <a:r>
+              <a:rPr sz="1400" dirty="0">
+                <a:solidFill>
+                  <a:srgbClr val="1A1A1A"/>
+                </a:solidFill>
+              </a:rPr>
+              <a:t>iven a positive + negative pair,</a:t>
             </a:r>
           </a:p>
           <a:p>
@@ -5002,7 +5015,12 @@
               </a:spcAft>
             </a:pPr>
             <a:r>
-              <a:t> </a:t>
+              <a:rPr sz="1400" dirty="0">
+                <a:solidFill>
+                  <a:srgbClr val="1A1A1A"/>
+                </a:solidFill>
+              </a:rPr>
+              <a:t>the model ranks the positive higher 82 % of the time.</a:t>
             </a:r>
           </a:p>
           <a:p>
@@ -5012,12 +5030,8 @@
               </a:spcAft>
             </a:pPr>
             <a:r>
-              <a:rPr sz="1400">
-                <a:solidFill>
-                  <a:srgbClr val="1A1A1A"/>
-                </a:solidFill>
-              </a:rPr>
-              <a:t>Why precision / F1 are tiny:  class_weight='balanced' is aggressive,</a:t>
+              <a:rPr dirty="0"/>
+              <a:t> </a:t>
             </a:r>
           </a:p>
           <a:p>
@@ -5027,12 +5041,28 @@
               </a:spcAft>
             </a:pPr>
             <a:r>
-              <a:rPr sz="1400">
+              <a:rPr sz="1400" dirty="0">
                 <a:solidFill>
                   <a:srgbClr val="1A1A1A"/>
                 </a:solidFill>
               </a:rPr>
-              <a:t>so the model produces many false positives in absolute terms - but</a:t>
+              <a:t>Why precision / F1 are tiny:  </a:t>
+            </a:r>
+            <a:r>
+              <a:rPr sz="1400" dirty="0" err="1">
+                <a:solidFill>
+                  <a:srgbClr val="1A1A1A"/>
+                </a:solidFill>
+              </a:rPr>
+              <a:t>class_weight</a:t>
+            </a:r>
+            <a:r>
+              <a:rPr sz="1400" dirty="0">
+                <a:solidFill>
+                  <a:srgbClr val="1A1A1A"/>
+                </a:solidFill>
+              </a:rPr>
+              <a:t>='balanced' is aggressive,</a:t>
             </a:r>
           </a:p>
           <a:p>
@@ -5042,12 +5072,12 @@
               </a:spcAft>
             </a:pPr>
             <a:r>
-              <a:rPr sz="1400">
+              <a:rPr sz="1400" dirty="0">
                 <a:solidFill>
                   <a:srgbClr val="1A1A1A"/>
                 </a:solidFill>
               </a:rPr>
-              <a:t>very few in relative terms (negatives are 99.996 % of the data).</a:t>
+              <a:t>so the model produces many false positives in absolute terms - but</a:t>
             </a:r>
           </a:p>
           <a:p>
@@ -5057,7 +5087,12 @@
               </a:spcAft>
             </a:pPr>
             <a:r>
-              <a:t> </a:t>
+              <a:rPr sz="1400" dirty="0">
+                <a:solidFill>
+                  <a:srgbClr val="1A1A1A"/>
+                </a:solidFill>
+              </a:rPr>
+              <a:t>very few in relative terms (negatives are 99.996 % of the data).</a:t>
             </a:r>
           </a:p>
           <a:p>
@@ -5067,7 +5102,18 @@
               </a:spcAft>
             </a:pPr>
             <a:r>
-              <a:rPr sz="1400">
+              <a:rPr dirty="0"/>
+              <a:t> </a:t>
+            </a:r>
+          </a:p>
+          <a:p>
+            <a:pPr>
+              <a:spcAft>
+                <a:spcPts val="400"/>
+              </a:spcAft>
+            </a:pPr>
+            <a:r>
+              <a:rPr sz="1400" dirty="0">
                 <a:solidFill>
                   <a:srgbClr val="1A1A1A"/>
                 </a:solidFill>
@@ -11696,6 +11742,36 @@
           </a:p>
         </p:txBody>
       </p:sp>
+      <p:pic>
+        <p:nvPicPr>
+          <p:cNvPr id="8" name="Picture 7">
+            <a:extLst>
+              <a:ext uri="{FF2B5EF4-FFF2-40B4-BE49-F238E27FC236}">
+                <a16:creationId xmlns:a16="http://schemas.microsoft.com/office/drawing/2014/main" id="{88FDF608-E07E-751C-C663-9E267CEA9BAD}"/>
+              </a:ext>
+            </a:extLst>
+          </p:cNvPr>
+          <p:cNvPicPr>
+            <a:picLocks noChangeAspect="1"/>
+          </p:cNvPicPr>
+          <p:nvPr/>
+        </p:nvPicPr>
+        <p:blipFill>
+          <a:blip r:embed="rId3"/>
+          <a:stretch>
+            <a:fillRect/>
+          </a:stretch>
+        </p:blipFill>
+        <p:spPr>
+          <a:xfrm>
+            <a:off x="640080" y="5134935"/>
+            <a:ext cx="8353091" cy="1026790"/>
+          </a:xfrm>
+          <a:prstGeom prst="rect">
+            <a:avLst/>
+          </a:prstGeom>
+        </p:spPr>
+      </p:pic>
     </p:spTree>
   </p:cSld>
   <p:clrMapOvr>

</xml_diff>

<commit_message>
Add real-data demo presets + CICIDS defense + demo script docs
</commit_message>
<xml_diff>
--- a/PRESENTATION.pptx
+++ b/PRESENTATION.pptx
@@ -4,28 +4,31 @@
   <p:sldMasterIdLst>
     <p:sldMasterId id="2147483648" r:id="rId1"/>
   </p:sldMasterIdLst>
+  <p:notesMasterIdLst>
+    <p:notesMasterId r:id="rId21"/>
+  </p:notesMasterIdLst>
   <p:sldIdLst>
-    <p:sldId id="256" r:id="rId7"/>
-    <p:sldId id="257" r:id="rId9"/>
-    <p:sldId id="258" r:id="rId10"/>
-    <p:sldId id="259" r:id="rId11"/>
-    <p:sldId id="260" r:id="rId12"/>
-    <p:sldId id="261" r:id="rId13"/>
-    <p:sldId id="262" r:id="rId14"/>
-    <p:sldId id="263" r:id="rId15"/>
-    <p:sldId id="264" r:id="rId16"/>
-    <p:sldId id="265" r:id="rId17"/>
-    <p:sldId id="266" r:id="rId18"/>
-    <p:sldId id="267" r:id="rId19"/>
-    <p:sldId id="268" r:id="rId20"/>
-    <p:sldId id="269" r:id="rId21"/>
-    <p:sldId id="270" r:id="rId22"/>
-    <p:sldId id="271" r:id="rId23"/>
-    <p:sldId id="272" r:id="rId24"/>
-    <p:sldId id="273" r:id="rId25"/>
-    <p:sldId id="274" r:id="rId26"/>
+    <p:sldId id="256" r:id="rId2"/>
+    <p:sldId id="257" r:id="rId3"/>
+    <p:sldId id="258" r:id="rId4"/>
+    <p:sldId id="259" r:id="rId5"/>
+    <p:sldId id="260" r:id="rId6"/>
+    <p:sldId id="261" r:id="rId7"/>
+    <p:sldId id="262" r:id="rId8"/>
+    <p:sldId id="263" r:id="rId9"/>
+    <p:sldId id="264" r:id="rId10"/>
+    <p:sldId id="265" r:id="rId11"/>
+    <p:sldId id="266" r:id="rId12"/>
+    <p:sldId id="267" r:id="rId13"/>
+    <p:sldId id="268" r:id="rId14"/>
+    <p:sldId id="269" r:id="rId15"/>
+    <p:sldId id="270" r:id="rId16"/>
+    <p:sldId id="271" r:id="rId17"/>
+    <p:sldId id="272" r:id="rId18"/>
+    <p:sldId id="273" r:id="rId19"/>
+    <p:sldId id="274" r:id="rId20"/>
   </p:sldIdLst>
-  <p:sldSz cx="12191695" cy="6858000" type="screen4x3"/>
+  <p:sldSz cx="12192000" cy="6858000"/>
   <p:notesSz cx="6858000" cy="9144000"/>
   <p:defaultTextStyle>
     <a:defPPr>
@@ -122,11 +125,27 @@
       </a:defRPr>
     </a:lvl9pPr>
   </p:defaultTextStyle>
+  <p:extLst>
+    <p:ext uri="{EFAFB233-063F-42B5-8137-9DF3F51BA10A}">
+      <p15:sldGuideLst xmlns:p15="http://schemas.microsoft.com/office/powerpoint/2012/main">
+        <p15:guide id="1" orient="horz" pos="2160">
+          <p15:clr>
+            <a:srgbClr val="A4A3A4"/>
+          </p15:clr>
+        </p15:guide>
+        <p15:guide id="2" pos="2880">
+          <p15:clr>
+            <a:srgbClr val="A4A3A4"/>
+          </p15:clr>
+        </p15:guide>
+      </p15:sldGuideLst>
+    </p:ext>
+  </p:extLst>
 </p:presentation>
 </file>
 
 <file path=ppt/notesMasters/notesMaster1.xml><?xml version="1.0" encoding="utf-8"?>
-<p:notesMaster xmlns:a="http://schemas.openxmlformats.org/drawingml/2006/main" xmlns:p="http://schemas.openxmlformats.org/presentationml/2006/main" xmlns:r="http://schemas.openxmlformats.org/officeDocument/2006/relationships">
+<p:notesMaster xmlns:a="http://schemas.openxmlformats.org/drawingml/2006/main" xmlns:r="http://schemas.openxmlformats.org/officeDocument/2006/relationships" xmlns:p="http://schemas.openxmlformats.org/presentationml/2006/main">
   <p:cSld>
     <p:bg>
       <p:bgRef idx="1001">
@@ -147,241 +166,16 @@
           <a:chExt cx="0" cy="0"/>
         </a:xfrm>
       </p:grpSpPr>
-      <p:sp>
-        <p:nvSpPr>
-          <p:cNvPr id="2" name="Header Placeholder 1"/>
-          <p:cNvSpPr>
-            <a:spLocks noGrp="1"/>
-          </p:cNvSpPr>
-          <p:nvPr>
-            <p:ph type="hdr" sz="quarter"/>
-          </p:nvPr>
-        </p:nvSpPr>
-        <p:spPr>
-          <a:xfrm>
-            <a:off x="0" y="0"/>
-            <a:ext cx="2971800" cy="457200"/>
-          </a:xfrm>
-          <a:prstGeom prst="rect">
-            <a:avLst/>
-          </a:prstGeom>
-        </p:spPr>
-        <p:txBody>
-          <a:bodyPr vert="horz" lIns="91440" tIns="45720" rIns="91440" bIns="45720" rtlCol="0"/>
-          <a:lstStyle>
-            <a:lvl1pPr algn="l">
-              <a:defRPr sz="1200"/>
-            </a:lvl1pPr>
-          </a:lstStyle>
-          <a:p>
-            <a:endParaRPr lang="en-US"/>
-          </a:p>
-        </p:txBody>
-      </p:sp>
-      <p:sp>
-        <p:nvSpPr>
-          <p:cNvPr id="3" name="Date Placeholder 2"/>
-          <p:cNvSpPr>
-            <a:spLocks noGrp="1"/>
-          </p:cNvSpPr>
-          <p:nvPr>
-            <p:ph type="dt" idx="1"/>
-          </p:nvPr>
-        </p:nvSpPr>
-        <p:spPr>
-          <a:xfrm>
-            <a:off x="3884613" y="0"/>
-            <a:ext cx="2971800" cy="457200"/>
-          </a:xfrm>
-          <a:prstGeom prst="rect">
-            <a:avLst/>
-          </a:prstGeom>
-        </p:spPr>
-        <p:txBody>
-          <a:bodyPr vert="horz" lIns="91440" tIns="45720" rIns="91440" bIns="45720" rtlCol="0"/>
-          <a:lstStyle>
-            <a:lvl1pPr algn="r">
-              <a:defRPr sz="1200"/>
-            </a:lvl1pPr>
-          </a:lstStyle>
-          <a:p>
-            <a:fld id="{0F89C1C7-3DCD-1040-A9CF-14679D8B5DDD}" type="datetimeFigureOut">
-              <a:rPr lang="en-US" smtClean="0"/>
-              <a:t>10/17/16</a:t>
-            </a:fld>
-            <a:endParaRPr lang="en-US"/>
-          </a:p>
-        </p:txBody>
-      </p:sp>
-      <p:sp>
-        <p:nvSpPr>
-          <p:cNvPr id="4" name="Slide Image Placeholder 3"/>
-          <p:cNvSpPr>
-            <a:spLocks noGrp="1" noRot="1" noChangeAspect="1"/>
-          </p:cNvSpPr>
-          <p:nvPr>
-            <p:ph type="sldImg" idx="2"/>
-          </p:nvPr>
-        </p:nvSpPr>
-        <p:spPr>
-          <a:xfrm>
-            <a:off x="1143000" y="685800"/>
-            <a:ext cx="4572000" cy="3429000"/>
-          </a:xfrm>
-          <a:prstGeom prst="rect">
-            <a:avLst/>
-          </a:prstGeom>
-          <a:noFill/>
-          <a:ln w="12700">
-            <a:solidFill>
-              <a:prstClr val="black"/>
-            </a:solidFill>
-          </a:ln>
-        </p:spPr>
-        <p:txBody>
-          <a:bodyPr vert="horz" lIns="91440" tIns="45720" rIns="91440" bIns="45720" rtlCol="0" anchor="ctr"/>
-          <a:lstStyle/>
-          <a:p>
-            <a:endParaRPr lang="en-US"/>
-          </a:p>
-        </p:txBody>
-      </p:sp>
-      <p:sp>
-        <p:nvSpPr>
-          <p:cNvPr id="5" name="Notes Placeholder 4"/>
-          <p:cNvSpPr>
-            <a:spLocks noGrp="1"/>
-          </p:cNvSpPr>
-          <p:nvPr>
-            <p:ph type="body" sz="quarter" idx="3"/>
-          </p:nvPr>
-        </p:nvSpPr>
-        <p:spPr>
-          <a:xfrm>
-            <a:off x="685800" y="4343400"/>
-            <a:ext cx="5486400" cy="4114800"/>
-          </a:xfrm>
-          <a:prstGeom prst="rect">
-            <a:avLst/>
-          </a:prstGeom>
-        </p:spPr>
-        <p:txBody>
-          <a:bodyPr vert="horz" lIns="91440" tIns="45720" rIns="91440" bIns="45720" rtlCol="0"/>
-          <a:lstStyle/>
-          <a:p>
-            <a:pPr lvl="0"/>
-            <a:r>
-              <a:rPr lang="en-US" smtClean="0"/>
-              <a:t>Click to edit Master text styles</a:t>
-            </a:r>
-          </a:p>
-          <a:p>
-            <a:pPr lvl="1"/>
-            <a:r>
-              <a:rPr lang="en-US" smtClean="0"/>
-              <a:t>Second level</a:t>
-            </a:r>
-          </a:p>
-          <a:p>
-            <a:pPr lvl="2"/>
-            <a:r>
-              <a:rPr lang="en-US" smtClean="0"/>
-              <a:t>Third level</a:t>
-            </a:r>
-          </a:p>
-          <a:p>
-            <a:pPr lvl="3"/>
-            <a:r>
-              <a:rPr lang="en-US" smtClean="0"/>
-              <a:t>Fourth level</a:t>
-            </a:r>
-          </a:p>
-          <a:p>
-            <a:pPr lvl="4"/>
-            <a:r>
-              <a:rPr lang="en-US" smtClean="0"/>
-              <a:t>Fifth level</a:t>
-            </a:r>
-            <a:endParaRPr lang="en-US"/>
-          </a:p>
-        </p:txBody>
-      </p:sp>
-      <p:sp>
-        <p:nvSpPr>
-          <p:cNvPr id="6" name="Footer Placeholder 5"/>
-          <p:cNvSpPr>
-            <a:spLocks noGrp="1"/>
-          </p:cNvSpPr>
-          <p:nvPr>
-            <p:ph type="ftr" sz="quarter" idx="4"/>
-          </p:nvPr>
-        </p:nvSpPr>
-        <p:spPr>
-          <a:xfrm>
-            <a:off x="0" y="8685213"/>
-            <a:ext cx="2971800" cy="457200"/>
-          </a:xfrm>
-          <a:prstGeom prst="rect">
-            <a:avLst/>
-          </a:prstGeom>
-        </p:spPr>
-        <p:txBody>
-          <a:bodyPr vert="horz" lIns="91440" tIns="45720" rIns="91440" bIns="45720" rtlCol="0" anchor="b"/>
-          <a:lstStyle>
-            <a:lvl1pPr algn="l">
-              <a:defRPr sz="1200"/>
-            </a:lvl1pPr>
-          </a:lstStyle>
-          <a:p>
-            <a:endParaRPr lang="en-US"/>
-          </a:p>
-        </p:txBody>
-      </p:sp>
-      <p:sp>
-        <p:nvSpPr>
-          <p:cNvPr id="7" name="Slide Number Placeholder 6"/>
-          <p:cNvSpPr>
-            <a:spLocks noGrp="1"/>
-          </p:cNvSpPr>
-          <p:nvPr>
-            <p:ph type="sldNum" sz="quarter" idx="5"/>
-          </p:nvPr>
-        </p:nvSpPr>
-        <p:spPr>
-          <a:xfrm>
-            <a:off x="3884613" y="8685213"/>
-            <a:ext cx="2971800" cy="457200"/>
-          </a:xfrm>
-          <a:prstGeom prst="rect">
-            <a:avLst/>
-          </a:prstGeom>
-        </p:spPr>
-        <p:txBody>
-          <a:bodyPr vert="horz" lIns="91440" tIns="45720" rIns="91440" bIns="45720" rtlCol="0" anchor="b"/>
-          <a:lstStyle>
-            <a:lvl1pPr algn="r">
-              <a:defRPr sz="1200"/>
-            </a:lvl1pPr>
-          </a:lstStyle>
-          <a:p>
-            <a:fld id="{BB5E49A5-4136-284D-997B-48E1D791AD67}" type="slidenum">
-              <a:rPr lang="en-US" smtClean="0"/>
-              <a:t>‹#›</a:t>
-            </a:fld>
-            <a:endParaRPr lang="en-US"/>
-          </a:p>
-        </p:txBody>
-      </p:sp>
     </p:spTree>
     <p:extLst>
       <p:ext uri="{BB962C8B-B14F-4D97-AF65-F5344CB8AC3E}">
-        <p14:creationId xmlns:p14="http://schemas.microsoft.com/office/powerpoint/2010/main" val="2623252185"/>
+        <p14:creationId xmlns:p14="http://schemas.microsoft.com/office/powerpoint/2010/main" val="4235548486"/>
       </p:ext>
     </p:extLst>
   </p:cSld>
   <p:clrMap bg1="lt1" tx1="dk1" bg2="lt2" tx2="dk2" accent1="accent1" accent2="accent2" accent3="accent3" accent4="accent4" accent5="accent5" accent6="accent6" hlink="hlink" folHlink="folHlink"/>
   <p:notesStyle>
-    <a:lvl1pPr marL="0" algn="l" defTabSz="457200" rtl="0" eaLnBrk="1" latinLnBrk="0" hangingPunct="1">
+    <a:lvl1pPr marL="0" algn="l" defTabSz="914400" rtl="0" eaLnBrk="1" latinLnBrk="0" hangingPunct="1">
       <a:defRPr sz="1200" kern="1200">
         <a:solidFill>
           <a:schemeClr val="tx1"/>
@@ -391,7 +185,7 @@
         <a:cs typeface="+mn-cs"/>
       </a:defRPr>
     </a:lvl1pPr>
-    <a:lvl2pPr marL="457200" algn="l" defTabSz="457200" rtl="0" eaLnBrk="1" latinLnBrk="0" hangingPunct="1">
+    <a:lvl2pPr marL="457200" algn="l" defTabSz="914400" rtl="0" eaLnBrk="1" latinLnBrk="0" hangingPunct="1">
       <a:defRPr sz="1200" kern="1200">
         <a:solidFill>
           <a:schemeClr val="tx1"/>
@@ -401,7 +195,7 @@
         <a:cs typeface="+mn-cs"/>
       </a:defRPr>
     </a:lvl2pPr>
-    <a:lvl3pPr marL="914400" algn="l" defTabSz="457200" rtl="0" eaLnBrk="1" latinLnBrk="0" hangingPunct="1">
+    <a:lvl3pPr marL="914400" algn="l" defTabSz="914400" rtl="0" eaLnBrk="1" latinLnBrk="0" hangingPunct="1">
       <a:defRPr sz="1200" kern="1200">
         <a:solidFill>
           <a:schemeClr val="tx1"/>
@@ -411,7 +205,7 @@
         <a:cs typeface="+mn-cs"/>
       </a:defRPr>
     </a:lvl3pPr>
-    <a:lvl4pPr marL="1371600" algn="l" defTabSz="457200" rtl="0" eaLnBrk="1" latinLnBrk="0" hangingPunct="1">
+    <a:lvl4pPr marL="1371600" algn="l" defTabSz="914400" rtl="0" eaLnBrk="1" latinLnBrk="0" hangingPunct="1">
       <a:defRPr sz="1200" kern="1200">
         <a:solidFill>
           <a:schemeClr val="tx1"/>
@@ -421,7 +215,7 @@
         <a:cs typeface="+mn-cs"/>
       </a:defRPr>
     </a:lvl4pPr>
-    <a:lvl5pPr marL="1828800" algn="l" defTabSz="457200" rtl="0" eaLnBrk="1" latinLnBrk="0" hangingPunct="1">
+    <a:lvl5pPr marL="1828800" algn="l" defTabSz="914400" rtl="0" eaLnBrk="1" latinLnBrk="0" hangingPunct="1">
       <a:defRPr sz="1200" kern="1200">
         <a:solidFill>
           <a:schemeClr val="tx1"/>
@@ -431,7 +225,7 @@
         <a:cs typeface="+mn-cs"/>
       </a:defRPr>
     </a:lvl5pPr>
-    <a:lvl6pPr marL="2286000" algn="l" defTabSz="457200" rtl="0" eaLnBrk="1" latinLnBrk="0" hangingPunct="1">
+    <a:lvl6pPr marL="2286000" algn="l" defTabSz="914400" rtl="0" eaLnBrk="1" latinLnBrk="0" hangingPunct="1">
       <a:defRPr sz="1200" kern="1200">
         <a:solidFill>
           <a:schemeClr val="tx1"/>
@@ -441,7 +235,7 @@
         <a:cs typeface="+mn-cs"/>
       </a:defRPr>
     </a:lvl6pPr>
-    <a:lvl7pPr marL="2743200" algn="l" defTabSz="457200" rtl="0" eaLnBrk="1" latinLnBrk="0" hangingPunct="1">
+    <a:lvl7pPr marL="2743200" algn="l" defTabSz="914400" rtl="0" eaLnBrk="1" latinLnBrk="0" hangingPunct="1">
       <a:defRPr sz="1200" kern="1200">
         <a:solidFill>
           <a:schemeClr val="tx1"/>
@@ -451,7 +245,7 @@
         <a:cs typeface="+mn-cs"/>
       </a:defRPr>
     </a:lvl7pPr>
-    <a:lvl8pPr marL="3200400" algn="l" defTabSz="457200" rtl="0" eaLnBrk="1" latinLnBrk="0" hangingPunct="1">
+    <a:lvl8pPr marL="3200400" algn="l" defTabSz="914400" rtl="0" eaLnBrk="1" latinLnBrk="0" hangingPunct="1">
       <a:defRPr sz="1200" kern="1200">
         <a:solidFill>
           <a:schemeClr val="tx1"/>
@@ -461,7 +255,7 @@
         <a:cs typeface="+mn-cs"/>
       </a:defRPr>
     </a:lvl8pPr>
-    <a:lvl9pPr marL="3657600" algn="l" defTabSz="457200" rtl="0" eaLnBrk="1" latinLnBrk="0" hangingPunct="1">
+    <a:lvl9pPr marL="3657600" algn="l" defTabSz="914400" rtl="0" eaLnBrk="1" latinLnBrk="0" hangingPunct="1">
       <a:defRPr sz="1200" kern="1200">
         <a:solidFill>
           <a:schemeClr val="tx1"/>
@@ -476,7 +270,7 @@
 </file>
 
 <file path=ppt/notesSlides/notesSlide1.xml><?xml version="1.0" encoding="utf-8"?>
-<p:notes xmlns:a="http://schemas.openxmlformats.org/drawingml/2006/main" xmlns:p="http://schemas.openxmlformats.org/presentationml/2006/main" xmlns:r="http://schemas.openxmlformats.org/officeDocument/2006/relationships">
+<p:notes xmlns:a="http://schemas.openxmlformats.org/drawingml/2006/main" xmlns:r="http://schemas.openxmlformats.org/officeDocument/2006/relationships" xmlns:p="http://schemas.openxmlformats.org/presentationml/2006/main">
   <p:cSld>
     <p:spTree>
       <p:nvGrpSpPr>
@@ -496,7 +290,7 @@
         <p:nvSpPr>
           <p:cNvPr id="2" name="Slide Image Placeholder 1"/>
           <p:cNvSpPr>
-            <a:spLocks noGrp="1"/>
+            <a:spLocks noGrp="1" noRot="1" noChangeAspect="1"/>
           </p:cNvSpPr>
           <p:nvPr>
             <p:ph type="sldImg" idx="2"/>
@@ -511,7 +305,7 @@
             <a:spLocks noGrp="1"/>
           </p:cNvSpPr>
           <p:nvPr>
-            <p:ph type="body" idx="3" sz="quarter"/>
+            <p:ph type="body" sz="quarter" idx="3"/>
           </p:nvPr>
         </p:nvSpPr>
         <p:spPr/>
@@ -532,7 +326,7 @@
             <a:spLocks noGrp="1"/>
           </p:cNvSpPr>
           <p:nvPr>
-            <p:ph type="sldNum" idx="5" sz="quarter"/>
+            <p:ph type="sldNum" sz="quarter" idx="5"/>
           </p:nvPr>
         </p:nvSpPr>
         <p:spPr/>
@@ -546,7 +340,7 @@
 </file>
 
 <file path=ppt/notesSlides/notesSlide10.xml><?xml version="1.0" encoding="utf-8"?>
-<p:notes xmlns:a="http://schemas.openxmlformats.org/drawingml/2006/main" xmlns:p="http://schemas.openxmlformats.org/presentationml/2006/main" xmlns:r="http://schemas.openxmlformats.org/officeDocument/2006/relationships">
+<p:notes xmlns:a="http://schemas.openxmlformats.org/drawingml/2006/main" xmlns:r="http://schemas.openxmlformats.org/officeDocument/2006/relationships" xmlns:p="http://schemas.openxmlformats.org/presentationml/2006/main">
   <p:cSld>
     <p:spTree>
       <p:nvGrpSpPr>
@@ -566,7 +360,7 @@
         <p:nvSpPr>
           <p:cNvPr id="2" name="Slide Image Placeholder 1"/>
           <p:cNvSpPr>
-            <a:spLocks noGrp="1"/>
+            <a:spLocks noGrp="1" noRot="1" noChangeAspect="1"/>
           </p:cNvSpPr>
           <p:nvPr>
             <p:ph type="sldImg" idx="2"/>
@@ -581,7 +375,7 @@
             <a:spLocks noGrp="1"/>
           </p:cNvSpPr>
           <p:nvPr>
-            <p:ph type="body" idx="3" sz="quarter"/>
+            <p:ph type="body" sz="quarter" idx="3"/>
           </p:nvPr>
         </p:nvSpPr>
         <p:spPr/>
@@ -602,7 +396,7 @@
             <a:spLocks noGrp="1"/>
           </p:cNvSpPr>
           <p:nvPr>
-            <p:ph type="sldNum" idx="5" sz="quarter"/>
+            <p:ph type="sldNum" sz="quarter" idx="5"/>
           </p:nvPr>
         </p:nvSpPr>
         <p:spPr/>
@@ -616,7 +410,7 @@
 </file>
 
 <file path=ppt/notesSlides/notesSlide11.xml><?xml version="1.0" encoding="utf-8"?>
-<p:notes xmlns:a="http://schemas.openxmlformats.org/drawingml/2006/main" xmlns:p="http://schemas.openxmlformats.org/presentationml/2006/main" xmlns:r="http://schemas.openxmlformats.org/officeDocument/2006/relationships">
+<p:notes xmlns:a="http://schemas.openxmlformats.org/drawingml/2006/main" xmlns:r="http://schemas.openxmlformats.org/officeDocument/2006/relationships" xmlns:p="http://schemas.openxmlformats.org/presentationml/2006/main">
   <p:cSld>
     <p:spTree>
       <p:nvGrpSpPr>
@@ -636,7 +430,7 @@
         <p:nvSpPr>
           <p:cNvPr id="2" name="Slide Image Placeholder 1"/>
           <p:cNvSpPr>
-            <a:spLocks noGrp="1"/>
+            <a:spLocks noGrp="1" noRot="1" noChangeAspect="1"/>
           </p:cNvSpPr>
           <p:nvPr>
             <p:ph type="sldImg" idx="2"/>
@@ -651,7 +445,7 @@
             <a:spLocks noGrp="1"/>
           </p:cNvSpPr>
           <p:nvPr>
-            <p:ph type="body" idx="3" sz="quarter"/>
+            <p:ph type="body" sz="quarter" idx="3"/>
           </p:nvPr>
         </p:nvSpPr>
         <p:spPr/>
@@ -672,7 +466,7 @@
             <a:spLocks noGrp="1"/>
           </p:cNvSpPr>
           <p:nvPr>
-            <p:ph type="sldNum" idx="5" sz="quarter"/>
+            <p:ph type="sldNum" sz="quarter" idx="5"/>
           </p:nvPr>
         </p:nvSpPr>
         <p:spPr/>
@@ -686,7 +480,7 @@
 </file>
 
 <file path=ppt/notesSlides/notesSlide12.xml><?xml version="1.0" encoding="utf-8"?>
-<p:notes xmlns:a="http://schemas.openxmlformats.org/drawingml/2006/main" xmlns:p="http://schemas.openxmlformats.org/presentationml/2006/main" xmlns:r="http://schemas.openxmlformats.org/officeDocument/2006/relationships">
+<p:notes xmlns:a="http://schemas.openxmlformats.org/drawingml/2006/main" xmlns:r="http://schemas.openxmlformats.org/officeDocument/2006/relationships" xmlns:p="http://schemas.openxmlformats.org/presentationml/2006/main">
   <p:cSld>
     <p:spTree>
       <p:nvGrpSpPr>
@@ -706,7 +500,7 @@
         <p:nvSpPr>
           <p:cNvPr id="2" name="Slide Image Placeholder 1"/>
           <p:cNvSpPr>
-            <a:spLocks noGrp="1"/>
+            <a:spLocks noGrp="1" noRot="1" noChangeAspect="1"/>
           </p:cNvSpPr>
           <p:nvPr>
             <p:ph type="sldImg" idx="2"/>
@@ -721,7 +515,7 @@
             <a:spLocks noGrp="1"/>
           </p:cNvSpPr>
           <p:nvPr>
-            <p:ph type="body" idx="3" sz="quarter"/>
+            <p:ph type="body" sz="quarter" idx="3"/>
           </p:nvPr>
         </p:nvSpPr>
         <p:spPr/>
@@ -742,7 +536,7 @@
             <a:spLocks noGrp="1"/>
           </p:cNvSpPr>
           <p:nvPr>
-            <p:ph type="sldNum" idx="5" sz="quarter"/>
+            <p:ph type="sldNum" sz="quarter" idx="5"/>
           </p:nvPr>
         </p:nvSpPr>
         <p:spPr/>
@@ -756,7 +550,7 @@
 </file>
 
 <file path=ppt/notesSlides/notesSlide13.xml><?xml version="1.0" encoding="utf-8"?>
-<p:notes xmlns:a="http://schemas.openxmlformats.org/drawingml/2006/main" xmlns:p="http://schemas.openxmlformats.org/presentationml/2006/main" xmlns:r="http://schemas.openxmlformats.org/officeDocument/2006/relationships">
+<p:notes xmlns:a="http://schemas.openxmlformats.org/drawingml/2006/main" xmlns:r="http://schemas.openxmlformats.org/officeDocument/2006/relationships" xmlns:p="http://schemas.openxmlformats.org/presentationml/2006/main">
   <p:cSld>
     <p:spTree>
       <p:nvGrpSpPr>
@@ -776,7 +570,7 @@
         <p:nvSpPr>
           <p:cNvPr id="2" name="Slide Image Placeholder 1"/>
           <p:cNvSpPr>
-            <a:spLocks noGrp="1"/>
+            <a:spLocks noGrp="1" noRot="1" noChangeAspect="1"/>
           </p:cNvSpPr>
           <p:nvPr>
             <p:ph type="sldImg" idx="2"/>
@@ -791,7 +585,7 @@
             <a:spLocks noGrp="1"/>
           </p:cNvSpPr>
           <p:nvPr>
-            <p:ph type="body" idx="3" sz="quarter"/>
+            <p:ph type="body" sz="quarter" idx="3"/>
           </p:nvPr>
         </p:nvSpPr>
         <p:spPr/>
@@ -812,7 +606,7 @@
             <a:spLocks noGrp="1"/>
           </p:cNvSpPr>
           <p:nvPr>
-            <p:ph type="sldNum" idx="5" sz="quarter"/>
+            <p:ph type="sldNum" sz="quarter" idx="5"/>
           </p:nvPr>
         </p:nvSpPr>
         <p:spPr/>
@@ -826,7 +620,7 @@
 </file>
 
 <file path=ppt/notesSlides/notesSlide14.xml><?xml version="1.0" encoding="utf-8"?>
-<p:notes xmlns:a="http://schemas.openxmlformats.org/drawingml/2006/main" xmlns:p="http://schemas.openxmlformats.org/presentationml/2006/main" xmlns:r="http://schemas.openxmlformats.org/officeDocument/2006/relationships">
+<p:notes xmlns:a="http://schemas.openxmlformats.org/drawingml/2006/main" xmlns:r="http://schemas.openxmlformats.org/officeDocument/2006/relationships" xmlns:p="http://schemas.openxmlformats.org/presentationml/2006/main">
   <p:cSld>
     <p:spTree>
       <p:nvGrpSpPr>
@@ -846,7 +640,7 @@
         <p:nvSpPr>
           <p:cNvPr id="2" name="Slide Image Placeholder 1"/>
           <p:cNvSpPr>
-            <a:spLocks noGrp="1"/>
+            <a:spLocks noGrp="1" noRot="1" noChangeAspect="1"/>
           </p:cNvSpPr>
           <p:nvPr>
             <p:ph type="sldImg" idx="2"/>
@@ -861,7 +655,7 @@
             <a:spLocks noGrp="1"/>
           </p:cNvSpPr>
           <p:nvPr>
-            <p:ph type="body" idx="3" sz="quarter"/>
+            <p:ph type="body" sz="quarter" idx="3"/>
           </p:nvPr>
         </p:nvSpPr>
         <p:spPr/>
@@ -882,7 +676,7 @@
             <a:spLocks noGrp="1"/>
           </p:cNvSpPr>
           <p:nvPr>
-            <p:ph type="sldNum" idx="5" sz="quarter"/>
+            <p:ph type="sldNum" sz="quarter" idx="5"/>
           </p:nvPr>
         </p:nvSpPr>
         <p:spPr/>
@@ -896,7 +690,7 @@
 </file>
 
 <file path=ppt/notesSlides/notesSlide15.xml><?xml version="1.0" encoding="utf-8"?>
-<p:notes xmlns:a="http://schemas.openxmlformats.org/drawingml/2006/main" xmlns:p="http://schemas.openxmlformats.org/presentationml/2006/main" xmlns:r="http://schemas.openxmlformats.org/officeDocument/2006/relationships">
+<p:notes xmlns:a="http://schemas.openxmlformats.org/drawingml/2006/main" xmlns:r="http://schemas.openxmlformats.org/officeDocument/2006/relationships" xmlns:p="http://schemas.openxmlformats.org/presentationml/2006/main">
   <p:cSld>
     <p:spTree>
       <p:nvGrpSpPr>
@@ -916,7 +710,7 @@
         <p:nvSpPr>
           <p:cNvPr id="2" name="Slide Image Placeholder 1"/>
           <p:cNvSpPr>
-            <a:spLocks noGrp="1"/>
+            <a:spLocks noGrp="1" noRot="1" noChangeAspect="1"/>
           </p:cNvSpPr>
           <p:nvPr>
             <p:ph type="sldImg" idx="2"/>
@@ -931,7 +725,7 @@
             <a:spLocks noGrp="1"/>
           </p:cNvSpPr>
           <p:nvPr>
-            <p:ph type="body" idx="3" sz="quarter"/>
+            <p:ph type="body" sz="quarter" idx="3"/>
           </p:nvPr>
         </p:nvSpPr>
         <p:spPr/>
@@ -952,7 +746,7 @@
             <a:spLocks noGrp="1"/>
           </p:cNvSpPr>
           <p:nvPr>
-            <p:ph type="sldNum" idx="5" sz="quarter"/>
+            <p:ph type="sldNum" sz="quarter" idx="5"/>
           </p:nvPr>
         </p:nvSpPr>
         <p:spPr/>
@@ -966,7 +760,7 @@
 </file>
 
 <file path=ppt/notesSlides/notesSlide16.xml><?xml version="1.0" encoding="utf-8"?>
-<p:notes xmlns:a="http://schemas.openxmlformats.org/drawingml/2006/main" xmlns:p="http://schemas.openxmlformats.org/presentationml/2006/main" xmlns:r="http://schemas.openxmlformats.org/officeDocument/2006/relationships">
+<p:notes xmlns:a="http://schemas.openxmlformats.org/drawingml/2006/main" xmlns:r="http://schemas.openxmlformats.org/officeDocument/2006/relationships" xmlns:p="http://schemas.openxmlformats.org/presentationml/2006/main">
   <p:cSld>
     <p:spTree>
       <p:nvGrpSpPr>
@@ -986,7 +780,7 @@
         <p:nvSpPr>
           <p:cNvPr id="2" name="Slide Image Placeholder 1"/>
           <p:cNvSpPr>
-            <a:spLocks noGrp="1"/>
+            <a:spLocks noGrp="1" noRot="1" noChangeAspect="1"/>
           </p:cNvSpPr>
           <p:nvPr>
             <p:ph type="sldImg" idx="2"/>
@@ -1001,7 +795,7 @@
             <a:spLocks noGrp="1"/>
           </p:cNvSpPr>
           <p:nvPr>
-            <p:ph type="body" idx="3" sz="quarter"/>
+            <p:ph type="body" sz="quarter" idx="3"/>
           </p:nvPr>
         </p:nvSpPr>
         <p:spPr/>
@@ -1022,7 +816,7 @@
             <a:spLocks noGrp="1"/>
           </p:cNvSpPr>
           <p:nvPr>
-            <p:ph type="sldNum" idx="5" sz="quarter"/>
+            <p:ph type="sldNum" sz="quarter" idx="5"/>
           </p:nvPr>
         </p:nvSpPr>
         <p:spPr/>
@@ -1036,7 +830,7 @@
 </file>
 
 <file path=ppt/notesSlides/notesSlide17.xml><?xml version="1.0" encoding="utf-8"?>
-<p:notes xmlns:a="http://schemas.openxmlformats.org/drawingml/2006/main" xmlns:p="http://schemas.openxmlformats.org/presentationml/2006/main" xmlns:r="http://schemas.openxmlformats.org/officeDocument/2006/relationships">
+<p:notes xmlns:a="http://schemas.openxmlformats.org/drawingml/2006/main" xmlns:r="http://schemas.openxmlformats.org/officeDocument/2006/relationships" xmlns:p="http://schemas.openxmlformats.org/presentationml/2006/main">
   <p:cSld>
     <p:spTree>
       <p:nvGrpSpPr>
@@ -1056,7 +850,7 @@
         <p:nvSpPr>
           <p:cNvPr id="2" name="Slide Image Placeholder 1"/>
           <p:cNvSpPr>
-            <a:spLocks noGrp="1"/>
+            <a:spLocks noGrp="1" noRot="1" noChangeAspect="1"/>
           </p:cNvSpPr>
           <p:nvPr>
             <p:ph type="sldImg" idx="2"/>
@@ -1071,7 +865,7 @@
             <a:spLocks noGrp="1"/>
           </p:cNvSpPr>
           <p:nvPr>
-            <p:ph type="body" idx="3" sz="quarter"/>
+            <p:ph type="body" sz="quarter" idx="3"/>
           </p:nvPr>
         </p:nvSpPr>
         <p:spPr/>
@@ -1092,7 +886,7 @@
             <a:spLocks noGrp="1"/>
           </p:cNvSpPr>
           <p:nvPr>
-            <p:ph type="sldNum" idx="5" sz="quarter"/>
+            <p:ph type="sldNum" sz="quarter" idx="5"/>
           </p:nvPr>
         </p:nvSpPr>
         <p:spPr/>
@@ -1106,7 +900,7 @@
 </file>
 
 <file path=ppt/notesSlides/notesSlide18.xml><?xml version="1.0" encoding="utf-8"?>
-<p:notes xmlns:a="http://schemas.openxmlformats.org/drawingml/2006/main" xmlns:p="http://schemas.openxmlformats.org/presentationml/2006/main" xmlns:r="http://schemas.openxmlformats.org/officeDocument/2006/relationships">
+<p:notes xmlns:a="http://schemas.openxmlformats.org/drawingml/2006/main" xmlns:r="http://schemas.openxmlformats.org/officeDocument/2006/relationships" xmlns:p="http://schemas.openxmlformats.org/presentationml/2006/main">
   <p:cSld>
     <p:spTree>
       <p:nvGrpSpPr>
@@ -1126,7 +920,7 @@
         <p:nvSpPr>
           <p:cNvPr id="2" name="Slide Image Placeholder 1"/>
           <p:cNvSpPr>
-            <a:spLocks noGrp="1"/>
+            <a:spLocks noGrp="1" noRot="1" noChangeAspect="1"/>
           </p:cNvSpPr>
           <p:nvPr>
             <p:ph type="sldImg" idx="2"/>
@@ -1141,7 +935,7 @@
             <a:spLocks noGrp="1"/>
           </p:cNvSpPr>
           <p:nvPr>
-            <p:ph type="body" idx="3" sz="quarter"/>
+            <p:ph type="body" sz="quarter" idx="3"/>
           </p:nvPr>
         </p:nvSpPr>
         <p:spPr/>
@@ -1162,7 +956,7 @@
             <a:spLocks noGrp="1"/>
           </p:cNvSpPr>
           <p:nvPr>
-            <p:ph type="sldNum" idx="5" sz="quarter"/>
+            <p:ph type="sldNum" sz="quarter" idx="5"/>
           </p:nvPr>
         </p:nvSpPr>
         <p:spPr/>
@@ -1176,7 +970,7 @@
 </file>
 
 <file path=ppt/notesSlides/notesSlide19.xml><?xml version="1.0" encoding="utf-8"?>
-<p:notes xmlns:a="http://schemas.openxmlformats.org/drawingml/2006/main" xmlns:p="http://schemas.openxmlformats.org/presentationml/2006/main" xmlns:r="http://schemas.openxmlformats.org/officeDocument/2006/relationships">
+<p:notes xmlns:a="http://schemas.openxmlformats.org/drawingml/2006/main" xmlns:r="http://schemas.openxmlformats.org/officeDocument/2006/relationships" xmlns:p="http://schemas.openxmlformats.org/presentationml/2006/main">
   <p:cSld>
     <p:spTree>
       <p:nvGrpSpPr>
@@ -1196,7 +990,7 @@
         <p:nvSpPr>
           <p:cNvPr id="2" name="Slide Image Placeholder 1"/>
           <p:cNvSpPr>
-            <a:spLocks noGrp="1"/>
+            <a:spLocks noGrp="1" noRot="1" noChangeAspect="1"/>
           </p:cNvSpPr>
           <p:nvPr>
             <p:ph type="sldImg" idx="2"/>
@@ -1211,7 +1005,7 @@
             <a:spLocks noGrp="1"/>
           </p:cNvSpPr>
           <p:nvPr>
-            <p:ph type="body" idx="3" sz="quarter"/>
+            <p:ph type="body" sz="quarter" idx="3"/>
           </p:nvPr>
         </p:nvSpPr>
         <p:spPr/>
@@ -1232,7 +1026,7 @@
             <a:spLocks noGrp="1"/>
           </p:cNvSpPr>
           <p:nvPr>
-            <p:ph type="sldNum" idx="5" sz="quarter"/>
+            <p:ph type="sldNum" sz="quarter" idx="5"/>
           </p:nvPr>
         </p:nvSpPr>
         <p:spPr/>
@@ -1246,7 +1040,7 @@
 </file>
 
 <file path=ppt/notesSlides/notesSlide2.xml><?xml version="1.0" encoding="utf-8"?>
-<p:notes xmlns:a="http://schemas.openxmlformats.org/drawingml/2006/main" xmlns:p="http://schemas.openxmlformats.org/presentationml/2006/main" xmlns:r="http://schemas.openxmlformats.org/officeDocument/2006/relationships">
+<p:notes xmlns:a="http://schemas.openxmlformats.org/drawingml/2006/main" xmlns:r="http://schemas.openxmlformats.org/officeDocument/2006/relationships" xmlns:p="http://schemas.openxmlformats.org/presentationml/2006/main">
   <p:cSld>
     <p:spTree>
       <p:nvGrpSpPr>
@@ -1266,7 +1060,7 @@
         <p:nvSpPr>
           <p:cNvPr id="2" name="Slide Image Placeholder 1"/>
           <p:cNvSpPr>
-            <a:spLocks noGrp="1"/>
+            <a:spLocks noGrp="1" noRot="1" noChangeAspect="1"/>
           </p:cNvSpPr>
           <p:nvPr>
             <p:ph type="sldImg" idx="2"/>
@@ -1281,7 +1075,7 @@
             <a:spLocks noGrp="1"/>
           </p:cNvSpPr>
           <p:nvPr>
-            <p:ph type="body" idx="3" sz="quarter"/>
+            <p:ph type="body" sz="quarter" idx="3"/>
           </p:nvPr>
         </p:nvSpPr>
         <p:spPr/>
@@ -1302,7 +1096,7 @@
             <a:spLocks noGrp="1"/>
           </p:cNvSpPr>
           <p:nvPr>
-            <p:ph type="sldNum" idx="5" sz="quarter"/>
+            <p:ph type="sldNum" sz="quarter" idx="5"/>
           </p:nvPr>
         </p:nvSpPr>
         <p:spPr/>
@@ -1316,7 +1110,7 @@
 </file>
 
 <file path=ppt/notesSlides/notesSlide3.xml><?xml version="1.0" encoding="utf-8"?>
-<p:notes xmlns:a="http://schemas.openxmlformats.org/drawingml/2006/main" xmlns:p="http://schemas.openxmlformats.org/presentationml/2006/main" xmlns:r="http://schemas.openxmlformats.org/officeDocument/2006/relationships">
+<p:notes xmlns:a="http://schemas.openxmlformats.org/drawingml/2006/main" xmlns:r="http://schemas.openxmlformats.org/officeDocument/2006/relationships" xmlns:p="http://schemas.openxmlformats.org/presentationml/2006/main">
   <p:cSld>
     <p:spTree>
       <p:nvGrpSpPr>
@@ -1336,7 +1130,7 @@
         <p:nvSpPr>
           <p:cNvPr id="2" name="Slide Image Placeholder 1"/>
           <p:cNvSpPr>
-            <a:spLocks noGrp="1"/>
+            <a:spLocks noGrp="1" noRot="1" noChangeAspect="1"/>
           </p:cNvSpPr>
           <p:nvPr>
             <p:ph type="sldImg" idx="2"/>
@@ -1351,7 +1145,7 @@
             <a:spLocks noGrp="1"/>
           </p:cNvSpPr>
           <p:nvPr>
-            <p:ph type="body" idx="3" sz="quarter"/>
+            <p:ph type="body" sz="quarter" idx="3"/>
           </p:nvPr>
         </p:nvSpPr>
         <p:spPr/>
@@ -1372,7 +1166,7 @@
             <a:spLocks noGrp="1"/>
           </p:cNvSpPr>
           <p:nvPr>
-            <p:ph type="sldNum" idx="5" sz="quarter"/>
+            <p:ph type="sldNum" sz="quarter" idx="5"/>
           </p:nvPr>
         </p:nvSpPr>
         <p:spPr/>
@@ -1386,7 +1180,7 @@
 </file>
 
 <file path=ppt/notesSlides/notesSlide4.xml><?xml version="1.0" encoding="utf-8"?>
-<p:notes xmlns:a="http://schemas.openxmlformats.org/drawingml/2006/main" xmlns:p="http://schemas.openxmlformats.org/presentationml/2006/main" xmlns:r="http://schemas.openxmlformats.org/officeDocument/2006/relationships">
+<p:notes xmlns:a="http://schemas.openxmlformats.org/drawingml/2006/main" xmlns:r="http://schemas.openxmlformats.org/officeDocument/2006/relationships" xmlns:p="http://schemas.openxmlformats.org/presentationml/2006/main">
   <p:cSld>
     <p:spTree>
       <p:nvGrpSpPr>
@@ -1406,7 +1200,7 @@
         <p:nvSpPr>
           <p:cNvPr id="2" name="Slide Image Placeholder 1"/>
           <p:cNvSpPr>
-            <a:spLocks noGrp="1"/>
+            <a:spLocks noGrp="1" noRot="1" noChangeAspect="1"/>
           </p:cNvSpPr>
           <p:nvPr>
             <p:ph type="sldImg" idx="2"/>
@@ -1421,7 +1215,7 @@
             <a:spLocks noGrp="1"/>
           </p:cNvSpPr>
           <p:nvPr>
-            <p:ph type="body" idx="3" sz="quarter"/>
+            <p:ph type="body" sz="quarter" idx="3"/>
           </p:nvPr>
         </p:nvSpPr>
         <p:spPr/>
@@ -1442,7 +1236,7 @@
             <a:spLocks noGrp="1"/>
           </p:cNvSpPr>
           <p:nvPr>
-            <p:ph type="sldNum" idx="5" sz="quarter"/>
+            <p:ph type="sldNum" sz="quarter" idx="5"/>
           </p:nvPr>
         </p:nvSpPr>
         <p:spPr/>
@@ -1456,7 +1250,7 @@
 </file>
 
 <file path=ppt/notesSlides/notesSlide5.xml><?xml version="1.0" encoding="utf-8"?>
-<p:notes xmlns:a="http://schemas.openxmlformats.org/drawingml/2006/main" xmlns:p="http://schemas.openxmlformats.org/presentationml/2006/main" xmlns:r="http://schemas.openxmlformats.org/officeDocument/2006/relationships">
+<p:notes xmlns:a="http://schemas.openxmlformats.org/drawingml/2006/main" xmlns:r="http://schemas.openxmlformats.org/officeDocument/2006/relationships" xmlns:p="http://schemas.openxmlformats.org/presentationml/2006/main">
   <p:cSld>
     <p:spTree>
       <p:nvGrpSpPr>
@@ -1476,7 +1270,7 @@
         <p:nvSpPr>
           <p:cNvPr id="2" name="Slide Image Placeholder 1"/>
           <p:cNvSpPr>
-            <a:spLocks noGrp="1"/>
+            <a:spLocks noGrp="1" noRot="1" noChangeAspect="1"/>
           </p:cNvSpPr>
           <p:nvPr>
             <p:ph type="sldImg" idx="2"/>
@@ -1491,7 +1285,7 @@
             <a:spLocks noGrp="1"/>
           </p:cNvSpPr>
           <p:nvPr>
-            <p:ph type="body" idx="3" sz="quarter"/>
+            <p:ph type="body" sz="quarter" idx="3"/>
           </p:nvPr>
         </p:nvSpPr>
         <p:spPr/>
@@ -1512,7 +1306,7 @@
             <a:spLocks noGrp="1"/>
           </p:cNvSpPr>
           <p:nvPr>
-            <p:ph type="sldNum" idx="5" sz="quarter"/>
+            <p:ph type="sldNum" sz="quarter" idx="5"/>
           </p:nvPr>
         </p:nvSpPr>
         <p:spPr/>
@@ -1526,7 +1320,7 @@
 </file>
 
 <file path=ppt/notesSlides/notesSlide6.xml><?xml version="1.0" encoding="utf-8"?>
-<p:notes xmlns:a="http://schemas.openxmlformats.org/drawingml/2006/main" xmlns:p="http://schemas.openxmlformats.org/presentationml/2006/main" xmlns:r="http://schemas.openxmlformats.org/officeDocument/2006/relationships">
+<p:notes xmlns:a="http://schemas.openxmlformats.org/drawingml/2006/main" xmlns:r="http://schemas.openxmlformats.org/officeDocument/2006/relationships" xmlns:p="http://schemas.openxmlformats.org/presentationml/2006/main">
   <p:cSld>
     <p:spTree>
       <p:nvGrpSpPr>
@@ -1546,7 +1340,7 @@
         <p:nvSpPr>
           <p:cNvPr id="2" name="Slide Image Placeholder 1"/>
           <p:cNvSpPr>
-            <a:spLocks noGrp="1"/>
+            <a:spLocks noGrp="1" noRot="1" noChangeAspect="1"/>
           </p:cNvSpPr>
           <p:nvPr>
             <p:ph type="sldImg" idx="2"/>
@@ -1561,7 +1355,7 @@
             <a:spLocks noGrp="1"/>
           </p:cNvSpPr>
           <p:nvPr>
-            <p:ph type="body" idx="3" sz="quarter"/>
+            <p:ph type="body" sz="quarter" idx="3"/>
           </p:nvPr>
         </p:nvSpPr>
         <p:spPr/>
@@ -1582,7 +1376,7 @@
             <a:spLocks noGrp="1"/>
           </p:cNvSpPr>
           <p:nvPr>
-            <p:ph type="sldNum" idx="5" sz="quarter"/>
+            <p:ph type="sldNum" sz="quarter" idx="5"/>
           </p:nvPr>
         </p:nvSpPr>
         <p:spPr/>
@@ -1596,7 +1390,7 @@
 </file>
 
 <file path=ppt/notesSlides/notesSlide7.xml><?xml version="1.0" encoding="utf-8"?>
-<p:notes xmlns:a="http://schemas.openxmlformats.org/drawingml/2006/main" xmlns:p="http://schemas.openxmlformats.org/presentationml/2006/main" xmlns:r="http://schemas.openxmlformats.org/officeDocument/2006/relationships">
+<p:notes xmlns:a="http://schemas.openxmlformats.org/drawingml/2006/main" xmlns:r="http://schemas.openxmlformats.org/officeDocument/2006/relationships" xmlns:p="http://schemas.openxmlformats.org/presentationml/2006/main">
   <p:cSld>
     <p:spTree>
       <p:nvGrpSpPr>
@@ -1616,7 +1410,7 @@
         <p:nvSpPr>
           <p:cNvPr id="2" name="Slide Image Placeholder 1"/>
           <p:cNvSpPr>
-            <a:spLocks noGrp="1"/>
+            <a:spLocks noGrp="1" noRot="1" noChangeAspect="1"/>
           </p:cNvSpPr>
           <p:nvPr>
             <p:ph type="sldImg" idx="2"/>
@@ -1631,7 +1425,7 @@
             <a:spLocks noGrp="1"/>
           </p:cNvSpPr>
           <p:nvPr>
-            <p:ph type="body" idx="3" sz="quarter"/>
+            <p:ph type="body" sz="quarter" idx="3"/>
           </p:nvPr>
         </p:nvSpPr>
         <p:spPr/>
@@ -1652,7 +1446,7 @@
             <a:spLocks noGrp="1"/>
           </p:cNvSpPr>
           <p:nvPr>
-            <p:ph type="sldNum" idx="5" sz="quarter"/>
+            <p:ph type="sldNum" sz="quarter" idx="5"/>
           </p:nvPr>
         </p:nvSpPr>
         <p:spPr/>
@@ -1666,7 +1460,7 @@
 </file>
 
 <file path=ppt/notesSlides/notesSlide8.xml><?xml version="1.0" encoding="utf-8"?>
-<p:notes xmlns:a="http://schemas.openxmlformats.org/drawingml/2006/main" xmlns:p="http://schemas.openxmlformats.org/presentationml/2006/main" xmlns:r="http://schemas.openxmlformats.org/officeDocument/2006/relationships">
+<p:notes xmlns:a="http://schemas.openxmlformats.org/drawingml/2006/main" xmlns:r="http://schemas.openxmlformats.org/officeDocument/2006/relationships" xmlns:p="http://schemas.openxmlformats.org/presentationml/2006/main">
   <p:cSld>
     <p:spTree>
       <p:nvGrpSpPr>
@@ -1686,7 +1480,7 @@
         <p:nvSpPr>
           <p:cNvPr id="2" name="Slide Image Placeholder 1"/>
           <p:cNvSpPr>
-            <a:spLocks noGrp="1"/>
+            <a:spLocks noGrp="1" noRot="1" noChangeAspect="1"/>
           </p:cNvSpPr>
           <p:nvPr>
             <p:ph type="sldImg" idx="2"/>
@@ -1701,7 +1495,7 @@
             <a:spLocks noGrp="1"/>
           </p:cNvSpPr>
           <p:nvPr>
-            <p:ph type="body" idx="3" sz="quarter"/>
+            <p:ph type="body" sz="quarter" idx="3"/>
           </p:nvPr>
         </p:nvSpPr>
         <p:spPr/>
@@ -1722,7 +1516,7 @@
             <a:spLocks noGrp="1"/>
           </p:cNvSpPr>
           <p:nvPr>
-            <p:ph type="sldNum" idx="5" sz="quarter"/>
+            <p:ph type="sldNum" sz="quarter" idx="5"/>
           </p:nvPr>
         </p:nvSpPr>
         <p:spPr/>
@@ -1736,7 +1530,7 @@
 </file>
 
 <file path=ppt/notesSlides/notesSlide9.xml><?xml version="1.0" encoding="utf-8"?>
-<p:notes xmlns:a="http://schemas.openxmlformats.org/drawingml/2006/main" xmlns:p="http://schemas.openxmlformats.org/presentationml/2006/main" xmlns:r="http://schemas.openxmlformats.org/officeDocument/2006/relationships">
+<p:notes xmlns:a="http://schemas.openxmlformats.org/drawingml/2006/main" xmlns:r="http://schemas.openxmlformats.org/officeDocument/2006/relationships" xmlns:p="http://schemas.openxmlformats.org/presentationml/2006/main">
   <p:cSld>
     <p:spTree>
       <p:nvGrpSpPr>
@@ -1756,7 +1550,7 @@
         <p:nvSpPr>
           <p:cNvPr id="2" name="Slide Image Placeholder 1"/>
           <p:cNvSpPr>
-            <a:spLocks noGrp="1"/>
+            <a:spLocks noGrp="1" noRot="1" noChangeAspect="1"/>
           </p:cNvSpPr>
           <p:nvPr>
             <p:ph type="sldImg" idx="2"/>
@@ -1771,7 +1565,7 @@
             <a:spLocks noGrp="1"/>
           </p:cNvSpPr>
           <p:nvPr>
-            <p:ph type="body" idx="3" sz="quarter"/>
+            <p:ph type="body" sz="quarter" idx="3"/>
           </p:nvPr>
         </p:nvSpPr>
         <p:spPr/>
@@ -1792,7 +1586,7 @@
             <a:spLocks noGrp="1"/>
           </p:cNvSpPr>
           <p:nvPr>
-            <p:ph type="sldNum" idx="5" sz="quarter"/>
+            <p:ph type="sldNum" sz="quarter" idx="5"/>
           </p:nvPr>
         </p:nvSpPr>
         <p:spPr/>
@@ -1843,10 +1637,9 @@
           <a:lstStyle/>
           <a:p>
             <a:r>
-              <a:rPr lang="en-US" smtClean="0"/>
+              <a:rPr lang="en-US"/>
               <a:t>Click to edit Master title style</a:t>
             </a:r>
-            <a:endParaRPr lang="en-US"/>
           </a:p>
         </p:txBody>
       </p:sp>
@@ -1962,10 +1755,9 @@
           </a:lstStyle>
           <a:p>
             <a:r>
-              <a:rPr lang="en-US" smtClean="0"/>
+              <a:rPr lang="en-US"/>
               <a:t>Click to edit Master subtitle style</a:t>
             </a:r>
-            <a:endParaRPr lang="en-US"/>
           </a:p>
         </p:txBody>
       </p:sp>
@@ -1986,7 +1778,7 @@
           <a:p>
             <a:fld id="{5BCAD085-E8A6-8845-BD4E-CB4CCA059FC4}" type="datetimeFigureOut">
               <a:rPr lang="en-US" smtClean="0"/>
-              <a:t>1/27/13</a:t>
+              <a:t>5/12/2026</a:t>
             </a:fld>
             <a:endParaRPr lang="en-US"/>
           </a:p>
@@ -2080,10 +1872,9 @@
           <a:lstStyle/>
           <a:p>
             <a:r>
-              <a:rPr lang="en-US" smtClean="0"/>
+              <a:rPr lang="en-US"/>
               <a:t>Click to edit Master title style</a:t>
             </a:r>
-            <a:endParaRPr lang="en-US"/>
           </a:p>
         </p:txBody>
       </p:sp>
@@ -2104,38 +1895,37 @@
           <a:p>
             <a:pPr lvl="0"/>
             <a:r>
-              <a:rPr lang="en-US" smtClean="0"/>
+              <a:rPr lang="en-US"/>
               <a:t>Click to edit Master text styles</a:t>
             </a:r>
           </a:p>
           <a:p>
             <a:pPr lvl="1"/>
             <a:r>
-              <a:rPr lang="en-US" smtClean="0"/>
+              <a:rPr lang="en-US"/>
               <a:t>Second level</a:t>
             </a:r>
           </a:p>
           <a:p>
             <a:pPr lvl="2"/>
             <a:r>
-              <a:rPr lang="en-US" smtClean="0"/>
+              <a:rPr lang="en-US"/>
               <a:t>Third level</a:t>
             </a:r>
           </a:p>
           <a:p>
             <a:pPr lvl="3"/>
             <a:r>
-              <a:rPr lang="en-US" smtClean="0"/>
+              <a:rPr lang="en-US"/>
               <a:t>Fourth level</a:t>
             </a:r>
           </a:p>
           <a:p>
             <a:pPr lvl="4"/>
             <a:r>
-              <a:rPr lang="en-US" smtClean="0"/>
+              <a:rPr lang="en-US"/>
               <a:t>Fifth level</a:t>
             </a:r>
-            <a:endParaRPr lang="en-US"/>
           </a:p>
         </p:txBody>
       </p:sp>
@@ -2156,7 +1946,7 @@
           <a:p>
             <a:fld id="{5BCAD085-E8A6-8845-BD4E-CB4CCA059FC4}" type="datetimeFigureOut">
               <a:rPr lang="en-US" smtClean="0"/>
-              <a:t>1/27/13</a:t>
+              <a:t>5/12/2026</a:t>
             </a:fld>
             <a:endParaRPr lang="en-US"/>
           </a:p>
@@ -2255,10 +2045,9 @@
           <a:lstStyle/>
           <a:p>
             <a:r>
-              <a:rPr lang="en-US" smtClean="0"/>
+              <a:rPr lang="en-US"/>
               <a:t>Click to edit Master title style</a:t>
             </a:r>
-            <a:endParaRPr lang="en-US"/>
           </a:p>
         </p:txBody>
       </p:sp>
@@ -2284,38 +2073,37 @@
           <a:p>
             <a:pPr lvl="0"/>
             <a:r>
-              <a:rPr lang="en-US" smtClean="0"/>
+              <a:rPr lang="en-US"/>
               <a:t>Click to edit Master text styles</a:t>
             </a:r>
           </a:p>
           <a:p>
             <a:pPr lvl="1"/>
             <a:r>
-              <a:rPr lang="en-US" smtClean="0"/>
+              <a:rPr lang="en-US"/>
               <a:t>Second level</a:t>
             </a:r>
           </a:p>
           <a:p>
             <a:pPr lvl="2"/>
             <a:r>
-              <a:rPr lang="en-US" smtClean="0"/>
+              <a:rPr lang="en-US"/>
               <a:t>Third level</a:t>
             </a:r>
           </a:p>
           <a:p>
             <a:pPr lvl="3"/>
             <a:r>
-              <a:rPr lang="en-US" smtClean="0"/>
+              <a:rPr lang="en-US"/>
               <a:t>Fourth level</a:t>
             </a:r>
           </a:p>
           <a:p>
             <a:pPr lvl="4"/>
             <a:r>
-              <a:rPr lang="en-US" smtClean="0"/>
+              <a:rPr lang="en-US"/>
               <a:t>Fifth level</a:t>
             </a:r>
-            <a:endParaRPr lang="en-US"/>
           </a:p>
         </p:txBody>
       </p:sp>
@@ -2336,7 +2124,7 @@
           <a:p>
             <a:fld id="{5BCAD085-E8A6-8845-BD4E-CB4CCA059FC4}" type="datetimeFigureOut">
               <a:rPr lang="en-US" smtClean="0"/>
-              <a:t>1/27/13</a:t>
+              <a:t>5/12/2026</a:t>
             </a:fld>
             <a:endParaRPr lang="en-US"/>
           </a:p>
@@ -2430,10 +2218,9 @@
           <a:lstStyle/>
           <a:p>
             <a:r>
-              <a:rPr lang="en-US" smtClean="0"/>
+              <a:rPr lang="en-US"/>
               <a:t>Click to edit Master title style</a:t>
             </a:r>
-            <a:endParaRPr lang="en-US"/>
           </a:p>
         </p:txBody>
       </p:sp>
@@ -2454,38 +2241,37 @@
           <a:p>
             <a:pPr lvl="0"/>
             <a:r>
-              <a:rPr lang="en-US" smtClean="0"/>
+              <a:rPr lang="en-US"/>
               <a:t>Click to edit Master text styles</a:t>
             </a:r>
           </a:p>
           <a:p>
             <a:pPr lvl="1"/>
             <a:r>
-              <a:rPr lang="en-US" smtClean="0"/>
+              <a:rPr lang="en-US"/>
               <a:t>Second level</a:t>
             </a:r>
           </a:p>
           <a:p>
             <a:pPr lvl="2"/>
             <a:r>
-              <a:rPr lang="en-US" smtClean="0"/>
+              <a:rPr lang="en-US"/>
               <a:t>Third level</a:t>
             </a:r>
           </a:p>
           <a:p>
             <a:pPr lvl="3"/>
             <a:r>
-              <a:rPr lang="en-US" smtClean="0"/>
+              <a:rPr lang="en-US"/>
               <a:t>Fourth level</a:t>
             </a:r>
           </a:p>
           <a:p>
             <a:pPr lvl="4"/>
             <a:r>
-              <a:rPr lang="en-US" smtClean="0"/>
+              <a:rPr lang="en-US"/>
               <a:t>Fifth level</a:t>
             </a:r>
-            <a:endParaRPr lang="en-US"/>
           </a:p>
         </p:txBody>
       </p:sp>
@@ -2506,7 +2292,7 @@
           <a:p>
             <a:fld id="{5BCAD085-E8A6-8845-BD4E-CB4CCA059FC4}" type="datetimeFigureOut">
               <a:rPr lang="en-US" smtClean="0"/>
-              <a:t>1/27/13</a:t>
+              <a:t>5/12/2026</a:t>
             </a:fld>
             <a:endParaRPr lang="en-US"/>
           </a:p>
@@ -2609,10 +2395,9 @@
           </a:lstStyle>
           <a:p>
             <a:r>
-              <a:rPr lang="en-US" smtClean="0"/>
+              <a:rPr lang="en-US"/>
               <a:t>Click to edit Master title style</a:t>
             </a:r>
-            <a:endParaRPr lang="en-US"/>
           </a:p>
         </p:txBody>
       </p:sp>
@@ -2729,7 +2514,7 @@
           <a:p>
             <a:pPr lvl="0"/>
             <a:r>
-              <a:rPr lang="en-US" smtClean="0"/>
+              <a:rPr lang="en-US"/>
               <a:t>Click to edit Master text styles</a:t>
             </a:r>
           </a:p>
@@ -2752,7 +2537,7 @@
           <a:p>
             <a:fld id="{5BCAD085-E8A6-8845-BD4E-CB4CCA059FC4}" type="datetimeFigureOut">
               <a:rPr lang="en-US" smtClean="0"/>
-              <a:t>1/27/13</a:t>
+              <a:t>5/12/2026</a:t>
             </a:fld>
             <a:endParaRPr lang="en-US"/>
           </a:p>
@@ -2846,10 +2631,9 @@
           <a:lstStyle/>
           <a:p>
             <a:r>
-              <a:rPr lang="en-US" smtClean="0"/>
+              <a:rPr lang="en-US"/>
               <a:t>Click to edit Master title style</a:t>
             </a:r>
-            <a:endParaRPr lang="en-US"/>
           </a:p>
         </p:txBody>
       </p:sp>
@@ -2903,38 +2687,37 @@
           <a:p>
             <a:pPr lvl="0"/>
             <a:r>
-              <a:rPr lang="en-US" smtClean="0"/>
+              <a:rPr lang="en-US"/>
               <a:t>Click to edit Master text styles</a:t>
             </a:r>
           </a:p>
           <a:p>
             <a:pPr lvl="1"/>
             <a:r>
-              <a:rPr lang="en-US" smtClean="0"/>
+              <a:rPr lang="en-US"/>
               <a:t>Second level</a:t>
             </a:r>
           </a:p>
           <a:p>
             <a:pPr lvl="2"/>
             <a:r>
-              <a:rPr lang="en-US" smtClean="0"/>
+              <a:rPr lang="en-US"/>
               <a:t>Third level</a:t>
             </a:r>
           </a:p>
           <a:p>
             <a:pPr lvl="3"/>
             <a:r>
-              <a:rPr lang="en-US" smtClean="0"/>
+              <a:rPr lang="en-US"/>
               <a:t>Fourth level</a:t>
             </a:r>
           </a:p>
           <a:p>
             <a:pPr lvl="4"/>
             <a:r>
-              <a:rPr lang="en-US" smtClean="0"/>
+              <a:rPr lang="en-US"/>
               <a:t>Fifth level</a:t>
             </a:r>
-            <a:endParaRPr lang="en-US"/>
           </a:p>
         </p:txBody>
       </p:sp>
@@ -2988,38 +2771,37 @@
           <a:p>
             <a:pPr lvl="0"/>
             <a:r>
-              <a:rPr lang="en-US" smtClean="0"/>
+              <a:rPr lang="en-US"/>
               <a:t>Click to edit Master text styles</a:t>
             </a:r>
           </a:p>
           <a:p>
             <a:pPr lvl="1"/>
             <a:r>
-              <a:rPr lang="en-US" smtClean="0"/>
+              <a:rPr lang="en-US"/>
               <a:t>Second level</a:t>
             </a:r>
           </a:p>
           <a:p>
             <a:pPr lvl="2"/>
             <a:r>
-              <a:rPr lang="en-US" smtClean="0"/>
+              <a:rPr lang="en-US"/>
               <a:t>Third level</a:t>
             </a:r>
           </a:p>
           <a:p>
             <a:pPr lvl="3"/>
             <a:r>
-              <a:rPr lang="en-US" smtClean="0"/>
+              <a:rPr lang="en-US"/>
               <a:t>Fourth level</a:t>
             </a:r>
           </a:p>
           <a:p>
             <a:pPr lvl="4"/>
             <a:r>
-              <a:rPr lang="en-US" smtClean="0"/>
+              <a:rPr lang="en-US"/>
               <a:t>Fifth level</a:t>
             </a:r>
-            <a:endParaRPr lang="en-US"/>
           </a:p>
         </p:txBody>
       </p:sp>
@@ -3040,7 +2822,7 @@
           <a:p>
             <a:fld id="{5BCAD085-E8A6-8845-BD4E-CB4CCA059FC4}" type="datetimeFigureOut">
               <a:rPr lang="en-US" smtClean="0"/>
-              <a:t>1/27/13</a:t>
+              <a:t>5/12/2026</a:t>
             </a:fld>
             <a:endParaRPr lang="en-US"/>
           </a:p>
@@ -3138,10 +2920,9 @@
           </a:lstStyle>
           <a:p>
             <a:r>
-              <a:rPr lang="en-US" smtClean="0"/>
+              <a:rPr lang="en-US"/>
               <a:t>Click to edit Master title style</a:t>
             </a:r>
-            <a:endParaRPr lang="en-US"/>
           </a:p>
         </p:txBody>
       </p:sp>
@@ -3204,7 +2985,7 @@
           <a:p>
             <a:pPr lvl="0"/>
             <a:r>
-              <a:rPr lang="en-US" smtClean="0"/>
+              <a:rPr lang="en-US"/>
               <a:t>Click to edit Master text styles</a:t>
             </a:r>
           </a:p>
@@ -3260,38 +3041,37 @@
           <a:p>
             <a:pPr lvl="0"/>
             <a:r>
-              <a:rPr lang="en-US" smtClean="0"/>
+              <a:rPr lang="en-US"/>
               <a:t>Click to edit Master text styles</a:t>
             </a:r>
           </a:p>
           <a:p>
             <a:pPr lvl="1"/>
             <a:r>
-              <a:rPr lang="en-US" smtClean="0"/>
+              <a:rPr lang="en-US"/>
               <a:t>Second level</a:t>
             </a:r>
           </a:p>
           <a:p>
             <a:pPr lvl="2"/>
             <a:r>
-              <a:rPr lang="en-US" smtClean="0"/>
+              <a:rPr lang="en-US"/>
               <a:t>Third level</a:t>
             </a:r>
           </a:p>
           <a:p>
             <a:pPr lvl="3"/>
             <a:r>
-              <a:rPr lang="en-US" smtClean="0"/>
+              <a:rPr lang="en-US"/>
               <a:t>Fourth level</a:t>
             </a:r>
           </a:p>
           <a:p>
             <a:pPr lvl="4"/>
             <a:r>
-              <a:rPr lang="en-US" smtClean="0"/>
+              <a:rPr lang="en-US"/>
               <a:t>Fifth level</a:t>
             </a:r>
-            <a:endParaRPr lang="en-US"/>
           </a:p>
         </p:txBody>
       </p:sp>
@@ -3354,7 +3134,7 @@
           <a:p>
             <a:pPr lvl="0"/>
             <a:r>
-              <a:rPr lang="en-US" smtClean="0"/>
+              <a:rPr lang="en-US"/>
               <a:t>Click to edit Master text styles</a:t>
             </a:r>
           </a:p>
@@ -3410,38 +3190,37 @@
           <a:p>
             <a:pPr lvl="0"/>
             <a:r>
-              <a:rPr lang="en-US" smtClean="0"/>
+              <a:rPr lang="en-US"/>
               <a:t>Click to edit Master text styles</a:t>
             </a:r>
           </a:p>
           <a:p>
             <a:pPr lvl="1"/>
             <a:r>
-              <a:rPr lang="en-US" smtClean="0"/>
+              <a:rPr lang="en-US"/>
               <a:t>Second level</a:t>
             </a:r>
           </a:p>
           <a:p>
             <a:pPr lvl="2"/>
             <a:r>
-              <a:rPr lang="en-US" smtClean="0"/>
+              <a:rPr lang="en-US"/>
               <a:t>Third level</a:t>
             </a:r>
           </a:p>
           <a:p>
             <a:pPr lvl="3"/>
             <a:r>
-              <a:rPr lang="en-US" smtClean="0"/>
+              <a:rPr lang="en-US"/>
               <a:t>Fourth level</a:t>
             </a:r>
           </a:p>
           <a:p>
             <a:pPr lvl="4"/>
             <a:r>
-              <a:rPr lang="en-US" smtClean="0"/>
+              <a:rPr lang="en-US"/>
               <a:t>Fifth level</a:t>
             </a:r>
-            <a:endParaRPr lang="en-US"/>
           </a:p>
         </p:txBody>
       </p:sp>
@@ -3462,7 +3241,7 @@
           <a:p>
             <a:fld id="{5BCAD085-E8A6-8845-BD4E-CB4CCA059FC4}" type="datetimeFigureOut">
               <a:rPr lang="en-US" smtClean="0"/>
-              <a:t>1/27/13</a:t>
+              <a:t>5/12/2026</a:t>
             </a:fld>
             <a:endParaRPr lang="en-US"/>
           </a:p>
@@ -3556,10 +3335,9 @@
           <a:lstStyle/>
           <a:p>
             <a:r>
-              <a:rPr lang="en-US" smtClean="0"/>
+              <a:rPr lang="en-US"/>
               <a:t>Click to edit Master title style</a:t>
             </a:r>
-            <a:endParaRPr lang="en-US"/>
           </a:p>
         </p:txBody>
       </p:sp>
@@ -3580,7 +3358,7 @@
           <a:p>
             <a:fld id="{5BCAD085-E8A6-8845-BD4E-CB4CCA059FC4}" type="datetimeFigureOut">
               <a:rPr lang="en-US" smtClean="0"/>
-              <a:t>1/27/13</a:t>
+              <a:t>5/12/2026</a:t>
             </a:fld>
             <a:endParaRPr lang="en-US"/>
           </a:p>
@@ -3675,7 +3453,7 @@
           <a:p>
             <a:fld id="{5BCAD085-E8A6-8845-BD4E-CB4CCA059FC4}" type="datetimeFigureOut">
               <a:rPr lang="en-US" smtClean="0"/>
-              <a:t>1/27/13</a:t>
+              <a:t>5/12/2026</a:t>
             </a:fld>
             <a:endParaRPr lang="en-US"/>
           </a:p>
@@ -3778,10 +3556,9 @@
           </a:lstStyle>
           <a:p>
             <a:r>
-              <a:rPr lang="en-US" smtClean="0"/>
+              <a:rPr lang="en-US"/>
               <a:t>Click to edit Master title style</a:t>
             </a:r>
-            <a:endParaRPr lang="en-US"/>
           </a:p>
         </p:txBody>
       </p:sp>
@@ -3835,38 +3612,37 @@
           <a:p>
             <a:pPr lvl="0"/>
             <a:r>
-              <a:rPr lang="en-US" smtClean="0"/>
+              <a:rPr lang="en-US"/>
               <a:t>Click to edit Master text styles</a:t>
             </a:r>
           </a:p>
           <a:p>
             <a:pPr lvl="1"/>
             <a:r>
-              <a:rPr lang="en-US" smtClean="0"/>
+              <a:rPr lang="en-US"/>
               <a:t>Second level</a:t>
             </a:r>
           </a:p>
           <a:p>
             <a:pPr lvl="2"/>
             <a:r>
-              <a:rPr lang="en-US" smtClean="0"/>
+              <a:rPr lang="en-US"/>
               <a:t>Third level</a:t>
             </a:r>
           </a:p>
           <a:p>
             <a:pPr lvl="3"/>
             <a:r>
-              <a:rPr lang="en-US" smtClean="0"/>
+              <a:rPr lang="en-US"/>
               <a:t>Fourth level</a:t>
             </a:r>
           </a:p>
           <a:p>
             <a:pPr lvl="4"/>
             <a:r>
-              <a:rPr lang="en-US" smtClean="0"/>
+              <a:rPr lang="en-US"/>
               <a:t>Fifth level</a:t>
             </a:r>
-            <a:endParaRPr lang="en-US"/>
           </a:p>
         </p:txBody>
       </p:sp>
@@ -3929,7 +3705,7 @@
           <a:p>
             <a:pPr lvl="0"/>
             <a:r>
-              <a:rPr lang="en-US" smtClean="0"/>
+              <a:rPr lang="en-US"/>
               <a:t>Click to edit Master text styles</a:t>
             </a:r>
           </a:p>
@@ -3952,7 +3728,7 @@
           <a:p>
             <a:fld id="{5BCAD085-E8A6-8845-BD4E-CB4CCA059FC4}" type="datetimeFigureOut">
               <a:rPr lang="en-US" smtClean="0"/>
-              <a:t>1/27/13</a:t>
+              <a:t>5/12/2026</a:t>
             </a:fld>
             <a:endParaRPr lang="en-US"/>
           </a:p>
@@ -4055,10 +3831,9 @@
           </a:lstStyle>
           <a:p>
             <a:r>
-              <a:rPr lang="en-US" smtClean="0"/>
+              <a:rPr lang="en-US"/>
               <a:t>Click to edit Master title style</a:t>
             </a:r>
-            <a:endParaRPr lang="en-US"/>
           </a:p>
         </p:txBody>
       </p:sp>
@@ -4182,7 +3957,7 @@
           <a:p>
             <a:pPr lvl="0"/>
             <a:r>
-              <a:rPr lang="en-US" smtClean="0"/>
+              <a:rPr lang="en-US"/>
               <a:t>Click to edit Master text styles</a:t>
             </a:r>
           </a:p>
@@ -4205,7 +3980,7 @@
           <a:p>
             <a:fld id="{5BCAD085-E8A6-8845-BD4E-CB4CCA059FC4}" type="datetimeFigureOut">
               <a:rPr lang="en-US" smtClean="0"/>
-              <a:t>1/27/13</a:t>
+              <a:t>5/12/2026</a:t>
             </a:fld>
             <a:endParaRPr lang="en-US"/>
           </a:p>
@@ -4314,10 +4089,9 @@
           <a:lstStyle/>
           <a:p>
             <a:r>
-              <a:rPr lang="en-US" smtClean="0"/>
+              <a:rPr lang="en-US"/>
               <a:t>Click to edit Master title style</a:t>
             </a:r>
-            <a:endParaRPr lang="en-US"/>
           </a:p>
         </p:txBody>
       </p:sp>
@@ -4348,38 +4122,37 @@
           <a:p>
             <a:pPr lvl="0"/>
             <a:r>
-              <a:rPr lang="en-US" smtClean="0"/>
+              <a:rPr lang="en-US"/>
               <a:t>Click to edit Master text styles</a:t>
             </a:r>
           </a:p>
           <a:p>
             <a:pPr lvl="1"/>
             <a:r>
-              <a:rPr lang="en-US" smtClean="0"/>
+              <a:rPr lang="en-US"/>
               <a:t>Second level</a:t>
             </a:r>
           </a:p>
           <a:p>
             <a:pPr lvl="2"/>
             <a:r>
-              <a:rPr lang="en-US" smtClean="0"/>
+              <a:rPr lang="en-US"/>
               <a:t>Third level</a:t>
             </a:r>
           </a:p>
           <a:p>
             <a:pPr lvl="3"/>
             <a:r>
-              <a:rPr lang="en-US" smtClean="0"/>
+              <a:rPr lang="en-US"/>
               <a:t>Fourth level</a:t>
             </a:r>
           </a:p>
           <a:p>
             <a:pPr lvl="4"/>
             <a:r>
-              <a:rPr lang="en-US" smtClean="0"/>
+              <a:rPr lang="en-US"/>
               <a:t>Fifth level</a:t>
             </a:r>
-            <a:endParaRPr lang="en-US"/>
           </a:p>
         </p:txBody>
       </p:sp>
@@ -4418,7 +4191,7 @@
           <a:p>
             <a:fld id="{5BCAD085-E8A6-8845-BD4E-CB4CCA059FC4}" type="datetimeFigureOut">
               <a:rPr lang="en-US" smtClean="0"/>
-              <a:t>1/27/13</a:t>
+              <a:t>5/12/2026</a:t>
             </a:fld>
             <a:endParaRPr lang="en-US"/>
           </a:p>
@@ -4777,7 +4550,7 @@
 </file>
 
 <file path=ppt/slides/slide1.xml><?xml version="1.0" encoding="utf-8"?>
-<p:sld xmlns:a="http://schemas.openxmlformats.org/drawingml/2006/main" xmlns:p="http://schemas.openxmlformats.org/presentationml/2006/main" xmlns:r="http://schemas.openxmlformats.org/officeDocument/2006/relationships">
+<p:sld xmlns:a="http://schemas.openxmlformats.org/drawingml/2006/main" xmlns:r="http://schemas.openxmlformats.org/officeDocument/2006/relationships" xmlns:p="http://schemas.openxmlformats.org/presentationml/2006/main">
   <p:cSld>
     <p:spTree>
       <p:nvGrpSpPr>
@@ -4785,7 +4558,14 @@
         <p:cNvGrpSpPr/>
         <p:nvPr/>
       </p:nvGrpSpPr>
-      <p:grpSpPr/>
+      <p:grpSpPr>
+        <a:xfrm>
+          <a:off x="0" y="0"/>
+          <a:ext cx="0" cy="0"/>
+          <a:chOff x="0" y="0"/>
+          <a:chExt cx="0" cy="0"/>
+        </a:xfrm>
+      </p:grpSpPr>
       <p:sp>
         <p:nvSpPr>
           <p:cNvPr id="2" name="Rectangle 1"/>
@@ -4826,6 +4606,7 @@
           <a:lstStyle/>
           <a:p>
             <a:pPr algn="ctr"/>
+            <a:endParaRPr/>
           </a:p>
         </p:txBody>
       </p:sp>
@@ -4869,6 +4650,7 @@
           <a:lstStyle/>
           <a:p>
             <a:pPr algn="ctr"/>
+            <a:endParaRPr/>
           </a:p>
         </p:txBody>
       </p:sp>
@@ -5071,7 +4853,7 @@
 </file>
 
 <file path=ppt/slides/slide10.xml><?xml version="1.0" encoding="utf-8"?>
-<p:sld xmlns:a="http://schemas.openxmlformats.org/drawingml/2006/main" xmlns:p="http://schemas.openxmlformats.org/presentationml/2006/main" xmlns:r="http://schemas.openxmlformats.org/officeDocument/2006/relationships">
+<p:sld xmlns:a="http://schemas.openxmlformats.org/drawingml/2006/main" xmlns:r="http://schemas.openxmlformats.org/officeDocument/2006/relationships" xmlns:p="http://schemas.openxmlformats.org/presentationml/2006/main">
   <p:cSld>
     <p:spTree>
       <p:nvGrpSpPr>
@@ -5079,7 +4861,14 @@
         <p:cNvGrpSpPr/>
         <p:nvPr/>
       </p:nvGrpSpPr>
-      <p:grpSpPr/>
+      <p:grpSpPr>
+        <a:xfrm>
+          <a:off x="0" y="0"/>
+          <a:ext cx="0" cy="0"/>
+          <a:chOff x="0" y="0"/>
+          <a:chExt cx="0" cy="0"/>
+        </a:xfrm>
+      </p:grpSpPr>
       <p:sp>
         <p:nvSpPr>
           <p:cNvPr id="2" name="Rectangle 1"/>
@@ -5120,6 +4909,7 @@
           <a:lstStyle/>
           <a:p>
             <a:pPr algn="ctr"/>
+            <a:endParaRPr/>
           </a:p>
         </p:txBody>
       </p:sp>
@@ -5163,6 +4953,7 @@
           <a:lstStyle/>
           <a:p>
             <a:pPr algn="ctr"/>
+            <a:endParaRPr/>
           </a:p>
         </p:txBody>
       </p:sp>
@@ -5430,7 +5221,7 @@
 </file>
 
 <file path=ppt/slides/slide11.xml><?xml version="1.0" encoding="utf-8"?>
-<p:sld xmlns:a="http://schemas.openxmlformats.org/drawingml/2006/main" xmlns:p="http://schemas.openxmlformats.org/presentationml/2006/main" xmlns:r="http://schemas.openxmlformats.org/officeDocument/2006/relationships">
+<p:sld xmlns:a="http://schemas.openxmlformats.org/drawingml/2006/main" xmlns:r="http://schemas.openxmlformats.org/officeDocument/2006/relationships" xmlns:p="http://schemas.openxmlformats.org/presentationml/2006/main">
   <p:cSld>
     <p:spTree>
       <p:nvGrpSpPr>
@@ -5438,7 +5229,14 @@
         <p:cNvGrpSpPr/>
         <p:nvPr/>
       </p:nvGrpSpPr>
-      <p:grpSpPr/>
+      <p:grpSpPr>
+        <a:xfrm>
+          <a:off x="0" y="0"/>
+          <a:ext cx="0" cy="0"/>
+          <a:chOff x="0" y="0"/>
+          <a:chExt cx="0" cy="0"/>
+        </a:xfrm>
+      </p:grpSpPr>
       <p:sp>
         <p:nvSpPr>
           <p:cNvPr id="2" name="Rectangle 1"/>
@@ -5479,6 +5277,7 @@
           <a:lstStyle/>
           <a:p>
             <a:pPr algn="ctr"/>
+            <a:endParaRPr/>
           </a:p>
         </p:txBody>
       </p:sp>
@@ -5522,6 +5321,7 @@
           <a:lstStyle/>
           <a:p>
             <a:pPr algn="ctr"/>
+            <a:endParaRPr/>
           </a:p>
         </p:txBody>
       </p:sp>
@@ -5789,7 +5589,7 @@
 </file>
 
 <file path=ppt/slides/slide12.xml><?xml version="1.0" encoding="utf-8"?>
-<p:sld xmlns:a="http://schemas.openxmlformats.org/drawingml/2006/main" xmlns:p="http://schemas.openxmlformats.org/presentationml/2006/main" xmlns:r="http://schemas.openxmlformats.org/officeDocument/2006/relationships">
+<p:sld xmlns:a="http://schemas.openxmlformats.org/drawingml/2006/main" xmlns:r="http://schemas.openxmlformats.org/officeDocument/2006/relationships" xmlns:p="http://schemas.openxmlformats.org/presentationml/2006/main">
   <p:cSld>
     <p:spTree>
       <p:nvGrpSpPr>
@@ -5797,7 +5597,14 @@
         <p:cNvGrpSpPr/>
         <p:nvPr/>
       </p:nvGrpSpPr>
-      <p:grpSpPr/>
+      <p:grpSpPr>
+        <a:xfrm>
+          <a:off x="0" y="0"/>
+          <a:ext cx="0" cy="0"/>
+          <a:chOff x="0" y="0"/>
+          <a:chExt cx="0" cy="0"/>
+        </a:xfrm>
+      </p:grpSpPr>
       <p:sp>
         <p:nvSpPr>
           <p:cNvPr id="2" name="Rectangle 1"/>
@@ -5838,6 +5645,7 @@
           <a:lstStyle/>
           <a:p>
             <a:pPr algn="ctr"/>
+            <a:endParaRPr/>
           </a:p>
         </p:txBody>
       </p:sp>
@@ -5881,6 +5689,7 @@
           <a:lstStyle/>
           <a:p>
             <a:pPr algn="ctr"/>
+            <a:endParaRPr/>
           </a:p>
         </p:txBody>
       </p:sp>
@@ -5958,6 +5767,7 @@
           <a:lstStyle/>
           <a:p>
             <a:pPr algn="ctr"/>
+            <a:endParaRPr/>
           </a:p>
         </p:txBody>
       </p:sp>
@@ -6104,6 +5914,7 @@
           <a:lstStyle/>
           <a:p>
             <a:pPr algn="ctr"/>
+            <a:endParaRPr/>
           </a:p>
         </p:txBody>
       </p:sp>
@@ -6250,6 +6061,7 @@
           <a:lstStyle/>
           <a:p>
             <a:pPr algn="ctr"/>
+            <a:endParaRPr/>
           </a:p>
         </p:txBody>
       </p:sp>
@@ -6396,6 +6208,7 @@
           <a:lstStyle/>
           <a:p>
             <a:pPr algn="ctr"/>
+            <a:endParaRPr/>
           </a:p>
         </p:txBody>
       </p:sp>
@@ -6542,6 +6355,7 @@
           <a:lstStyle/>
           <a:p>
             <a:pPr algn="ctr"/>
+            <a:endParaRPr/>
           </a:p>
         </p:txBody>
       </p:sp>
@@ -6688,6 +6502,7 @@
           <a:lstStyle/>
           <a:p>
             <a:pPr algn="ctr"/>
+            <a:endParaRPr/>
           </a:p>
         </p:txBody>
       </p:sp>
@@ -6834,6 +6649,7 @@
           <a:lstStyle/>
           <a:p>
             <a:pPr algn="ctr"/>
+            <a:endParaRPr/>
           </a:p>
         </p:txBody>
       </p:sp>
@@ -6980,6 +6796,7 @@
           <a:lstStyle/>
           <a:p>
             <a:pPr algn="ctr"/>
+            <a:endParaRPr/>
           </a:p>
         </p:txBody>
       </p:sp>
@@ -7095,7 +6912,7 @@
 </file>
 
 <file path=ppt/slides/slide13.xml><?xml version="1.0" encoding="utf-8"?>
-<p:sld xmlns:a="http://schemas.openxmlformats.org/drawingml/2006/main" xmlns:p="http://schemas.openxmlformats.org/presentationml/2006/main" xmlns:r="http://schemas.openxmlformats.org/officeDocument/2006/relationships">
+<p:sld xmlns:a="http://schemas.openxmlformats.org/drawingml/2006/main" xmlns:r="http://schemas.openxmlformats.org/officeDocument/2006/relationships" xmlns:p="http://schemas.openxmlformats.org/presentationml/2006/main">
   <p:cSld>
     <p:spTree>
       <p:nvGrpSpPr>
@@ -7103,7 +6920,14 @@
         <p:cNvGrpSpPr/>
         <p:nvPr/>
       </p:nvGrpSpPr>
-      <p:grpSpPr/>
+      <p:grpSpPr>
+        <a:xfrm>
+          <a:off x="0" y="0"/>
+          <a:ext cx="0" cy="0"/>
+          <a:chOff x="0" y="0"/>
+          <a:chExt cx="0" cy="0"/>
+        </a:xfrm>
+      </p:grpSpPr>
       <p:sp>
         <p:nvSpPr>
           <p:cNvPr id="2" name="Rectangle 1"/>
@@ -7144,6 +6968,7 @@
           <a:lstStyle/>
           <a:p>
             <a:pPr algn="ctr"/>
+            <a:endParaRPr/>
           </a:p>
         </p:txBody>
       </p:sp>
@@ -7187,6 +7012,7 @@
           <a:lstStyle/>
           <a:p>
             <a:pPr algn="ctr"/>
+            <a:endParaRPr/>
           </a:p>
         </p:txBody>
       </p:sp>
@@ -7514,7 +7340,7 @@
 </file>
 
 <file path=ppt/slides/slide14.xml><?xml version="1.0" encoding="utf-8"?>
-<p:sld xmlns:a="http://schemas.openxmlformats.org/drawingml/2006/main" xmlns:p="http://schemas.openxmlformats.org/presentationml/2006/main" xmlns:r="http://schemas.openxmlformats.org/officeDocument/2006/relationships">
+<p:sld xmlns:a="http://schemas.openxmlformats.org/drawingml/2006/main" xmlns:r="http://schemas.openxmlformats.org/officeDocument/2006/relationships" xmlns:p="http://schemas.openxmlformats.org/presentationml/2006/main">
   <p:cSld>
     <p:spTree>
       <p:nvGrpSpPr>
@@ -7522,7 +7348,14 @@
         <p:cNvGrpSpPr/>
         <p:nvPr/>
       </p:nvGrpSpPr>
-      <p:grpSpPr/>
+      <p:grpSpPr>
+        <a:xfrm>
+          <a:off x="0" y="0"/>
+          <a:ext cx="0" cy="0"/>
+          <a:chOff x="0" y="0"/>
+          <a:chExt cx="0" cy="0"/>
+        </a:xfrm>
+      </p:grpSpPr>
       <p:sp>
         <p:nvSpPr>
           <p:cNvPr id="2" name="Rectangle 1"/>
@@ -7563,6 +7396,7 @@
           <a:lstStyle/>
           <a:p>
             <a:pPr algn="ctr"/>
+            <a:endParaRPr/>
           </a:p>
         </p:txBody>
       </p:sp>
@@ -7606,6 +7440,7 @@
           <a:lstStyle/>
           <a:p>
             <a:pPr algn="ctr"/>
+            <a:endParaRPr/>
           </a:p>
         </p:txBody>
       </p:sp>
@@ -7948,7 +7783,7 @@
 </file>
 
 <file path=ppt/slides/slide15.xml><?xml version="1.0" encoding="utf-8"?>
-<p:sld xmlns:a="http://schemas.openxmlformats.org/drawingml/2006/main" xmlns:p="http://schemas.openxmlformats.org/presentationml/2006/main" xmlns:r="http://schemas.openxmlformats.org/officeDocument/2006/relationships">
+<p:sld xmlns:a="http://schemas.openxmlformats.org/drawingml/2006/main" xmlns:r="http://schemas.openxmlformats.org/officeDocument/2006/relationships" xmlns:p="http://schemas.openxmlformats.org/presentationml/2006/main">
   <p:cSld>
     <p:spTree>
       <p:nvGrpSpPr>
@@ -7956,7 +7791,14 @@
         <p:cNvGrpSpPr/>
         <p:nvPr/>
       </p:nvGrpSpPr>
-      <p:grpSpPr/>
+      <p:grpSpPr>
+        <a:xfrm>
+          <a:off x="0" y="0"/>
+          <a:ext cx="0" cy="0"/>
+          <a:chOff x="0" y="0"/>
+          <a:chExt cx="0" cy="0"/>
+        </a:xfrm>
+      </p:grpSpPr>
       <p:sp>
         <p:nvSpPr>
           <p:cNvPr id="2" name="Rectangle 1"/>
@@ -7997,6 +7839,7 @@
           <a:lstStyle/>
           <a:p>
             <a:pPr algn="ctr"/>
+            <a:endParaRPr/>
           </a:p>
         </p:txBody>
       </p:sp>
@@ -8040,6 +7883,7 @@
           <a:lstStyle/>
           <a:p>
             <a:pPr algn="ctr"/>
+            <a:endParaRPr/>
           </a:p>
         </p:txBody>
       </p:sp>
@@ -8509,7 +8353,7 @@
 </file>
 
 <file path=ppt/slides/slide16.xml><?xml version="1.0" encoding="utf-8"?>
-<p:sld xmlns:a="http://schemas.openxmlformats.org/drawingml/2006/main" xmlns:p="http://schemas.openxmlformats.org/presentationml/2006/main" xmlns:r="http://schemas.openxmlformats.org/officeDocument/2006/relationships">
+<p:sld xmlns:a="http://schemas.openxmlformats.org/drawingml/2006/main" xmlns:r="http://schemas.openxmlformats.org/officeDocument/2006/relationships" xmlns:p="http://schemas.openxmlformats.org/presentationml/2006/main">
   <p:cSld>
     <p:spTree>
       <p:nvGrpSpPr>
@@ -8517,7 +8361,14 @@
         <p:cNvGrpSpPr/>
         <p:nvPr/>
       </p:nvGrpSpPr>
-      <p:grpSpPr/>
+      <p:grpSpPr>
+        <a:xfrm>
+          <a:off x="0" y="0"/>
+          <a:ext cx="0" cy="0"/>
+          <a:chOff x="0" y="0"/>
+          <a:chExt cx="0" cy="0"/>
+        </a:xfrm>
+      </p:grpSpPr>
       <p:sp>
         <p:nvSpPr>
           <p:cNvPr id="2" name="Rectangle 1"/>
@@ -8558,6 +8409,7 @@
           <a:lstStyle/>
           <a:p>
             <a:pPr algn="ctr"/>
+            <a:endParaRPr/>
           </a:p>
         </p:txBody>
       </p:sp>
@@ -8601,6 +8453,7 @@
           <a:lstStyle/>
           <a:p>
             <a:pPr algn="ctr"/>
+            <a:endParaRPr/>
           </a:p>
         </p:txBody>
       </p:sp>
@@ -8899,7 +8752,7 @@
 </file>
 
 <file path=ppt/slides/slide17.xml><?xml version="1.0" encoding="utf-8"?>
-<p:sld xmlns:a="http://schemas.openxmlformats.org/drawingml/2006/main" xmlns:p="http://schemas.openxmlformats.org/presentationml/2006/main" xmlns:r="http://schemas.openxmlformats.org/officeDocument/2006/relationships">
+<p:sld xmlns:a="http://schemas.openxmlformats.org/drawingml/2006/main" xmlns:r="http://schemas.openxmlformats.org/officeDocument/2006/relationships" xmlns:p="http://schemas.openxmlformats.org/presentationml/2006/main">
   <p:cSld>
     <p:spTree>
       <p:nvGrpSpPr>
@@ -8907,7 +8760,14 @@
         <p:cNvGrpSpPr/>
         <p:nvPr/>
       </p:nvGrpSpPr>
-      <p:grpSpPr/>
+      <p:grpSpPr>
+        <a:xfrm>
+          <a:off x="0" y="0"/>
+          <a:ext cx="0" cy="0"/>
+          <a:chOff x="0" y="0"/>
+          <a:chExt cx="0" cy="0"/>
+        </a:xfrm>
+      </p:grpSpPr>
       <p:sp>
         <p:nvSpPr>
           <p:cNvPr id="2" name="Rectangle 1"/>
@@ -8948,6 +8808,7 @@
           <a:lstStyle/>
           <a:p>
             <a:pPr algn="ctr"/>
+            <a:endParaRPr/>
           </a:p>
         </p:txBody>
       </p:sp>
@@ -8991,6 +8852,7 @@
           <a:lstStyle/>
           <a:p>
             <a:pPr algn="ctr"/>
+            <a:endParaRPr/>
           </a:p>
         </p:txBody>
       </p:sp>
@@ -9129,7 +8991,7 @@
 </file>
 
 <file path=ppt/slides/slide18.xml><?xml version="1.0" encoding="utf-8"?>
-<p:sld xmlns:a="http://schemas.openxmlformats.org/drawingml/2006/main" xmlns:p="http://schemas.openxmlformats.org/presentationml/2006/main" xmlns:r="http://schemas.openxmlformats.org/officeDocument/2006/relationships">
+<p:sld xmlns:a="http://schemas.openxmlformats.org/drawingml/2006/main" xmlns:r="http://schemas.openxmlformats.org/officeDocument/2006/relationships" xmlns:p="http://schemas.openxmlformats.org/presentationml/2006/main">
   <p:cSld>
     <p:spTree>
       <p:nvGrpSpPr>
@@ -9137,7 +8999,14 @@
         <p:cNvGrpSpPr/>
         <p:nvPr/>
       </p:nvGrpSpPr>
-      <p:grpSpPr/>
+      <p:grpSpPr>
+        <a:xfrm>
+          <a:off x="0" y="0"/>
+          <a:ext cx="0" cy="0"/>
+          <a:chOff x="0" y="0"/>
+          <a:chExt cx="0" cy="0"/>
+        </a:xfrm>
+      </p:grpSpPr>
       <p:sp>
         <p:nvSpPr>
           <p:cNvPr id="2" name="Rectangle 1"/>
@@ -9178,6 +9047,7 @@
           <a:lstStyle/>
           <a:p>
             <a:pPr algn="ctr"/>
+            <a:endParaRPr/>
           </a:p>
         </p:txBody>
       </p:sp>
@@ -9221,6 +9091,7 @@
           <a:lstStyle/>
           <a:p>
             <a:pPr algn="ctr"/>
+            <a:endParaRPr/>
           </a:p>
         </p:txBody>
       </p:sp>
@@ -9580,7 +9451,7 @@
 </file>
 
 <file path=ppt/slides/slide19.xml><?xml version="1.0" encoding="utf-8"?>
-<p:sld xmlns:a="http://schemas.openxmlformats.org/drawingml/2006/main" xmlns:p="http://schemas.openxmlformats.org/presentationml/2006/main" xmlns:r="http://schemas.openxmlformats.org/officeDocument/2006/relationships">
+<p:sld xmlns:a="http://schemas.openxmlformats.org/drawingml/2006/main" xmlns:r="http://schemas.openxmlformats.org/officeDocument/2006/relationships" xmlns:p="http://schemas.openxmlformats.org/presentationml/2006/main">
   <p:cSld>
     <p:spTree>
       <p:nvGrpSpPr>
@@ -9588,7 +9459,14 @@
         <p:cNvGrpSpPr/>
         <p:nvPr/>
       </p:nvGrpSpPr>
-      <p:grpSpPr/>
+      <p:grpSpPr>
+        <a:xfrm>
+          <a:off x="0" y="0"/>
+          <a:ext cx="0" cy="0"/>
+          <a:chOff x="0" y="0"/>
+          <a:chExt cx="0" cy="0"/>
+        </a:xfrm>
+      </p:grpSpPr>
       <p:sp>
         <p:nvSpPr>
           <p:cNvPr id="2" name="Rectangle 1"/>
@@ -9629,6 +9507,7 @@
           <a:lstStyle/>
           <a:p>
             <a:pPr algn="ctr"/>
+            <a:endParaRPr/>
           </a:p>
         </p:txBody>
       </p:sp>
@@ -9672,6 +9551,7 @@
           <a:lstStyle/>
           <a:p>
             <a:pPr algn="ctr"/>
+            <a:endParaRPr/>
           </a:p>
         </p:txBody>
       </p:sp>
@@ -9823,7 +9703,7 @@
 </file>
 
 <file path=ppt/slides/slide2.xml><?xml version="1.0" encoding="utf-8"?>
-<p:sld xmlns:a="http://schemas.openxmlformats.org/drawingml/2006/main" xmlns:p="http://schemas.openxmlformats.org/presentationml/2006/main" xmlns:r="http://schemas.openxmlformats.org/officeDocument/2006/relationships">
+<p:sld xmlns:a="http://schemas.openxmlformats.org/drawingml/2006/main" xmlns:r="http://schemas.openxmlformats.org/officeDocument/2006/relationships" xmlns:p="http://schemas.openxmlformats.org/presentationml/2006/main">
   <p:cSld>
     <p:spTree>
       <p:nvGrpSpPr>
@@ -9831,7 +9711,14 @@
         <p:cNvGrpSpPr/>
         <p:nvPr/>
       </p:nvGrpSpPr>
-      <p:grpSpPr/>
+      <p:grpSpPr>
+        <a:xfrm>
+          <a:off x="0" y="0"/>
+          <a:ext cx="0" cy="0"/>
+          <a:chOff x="0" y="0"/>
+          <a:chExt cx="0" cy="0"/>
+        </a:xfrm>
+      </p:grpSpPr>
       <p:sp>
         <p:nvSpPr>
           <p:cNvPr id="2" name="Rectangle 1"/>
@@ -9872,6 +9759,7 @@
           <a:lstStyle/>
           <a:p>
             <a:pPr algn="ctr"/>
+            <a:endParaRPr/>
           </a:p>
         </p:txBody>
       </p:sp>
@@ -9915,6 +9803,7 @@
           <a:lstStyle/>
           <a:p>
             <a:pPr algn="ctr"/>
+            <a:endParaRPr/>
           </a:p>
         </p:txBody>
       </p:sp>
@@ -10153,7 +10042,7 @@
 </file>
 
 <file path=ppt/slides/slide3.xml><?xml version="1.0" encoding="utf-8"?>
-<p:sld xmlns:a="http://schemas.openxmlformats.org/drawingml/2006/main" xmlns:p="http://schemas.openxmlformats.org/presentationml/2006/main" xmlns:r="http://schemas.openxmlformats.org/officeDocument/2006/relationships">
+<p:sld xmlns:a="http://schemas.openxmlformats.org/drawingml/2006/main" xmlns:r="http://schemas.openxmlformats.org/officeDocument/2006/relationships" xmlns:p="http://schemas.openxmlformats.org/presentationml/2006/main">
   <p:cSld>
     <p:spTree>
       <p:nvGrpSpPr>
@@ -10161,7 +10050,14 @@
         <p:cNvGrpSpPr/>
         <p:nvPr/>
       </p:nvGrpSpPr>
-      <p:grpSpPr/>
+      <p:grpSpPr>
+        <a:xfrm>
+          <a:off x="0" y="0"/>
+          <a:ext cx="0" cy="0"/>
+          <a:chOff x="0" y="0"/>
+          <a:chExt cx="0" cy="0"/>
+        </a:xfrm>
+      </p:grpSpPr>
       <p:sp>
         <p:nvSpPr>
           <p:cNvPr id="2" name="Rectangle 1"/>
@@ -10202,6 +10098,7 @@
           <a:lstStyle/>
           <a:p>
             <a:pPr algn="ctr"/>
+            <a:endParaRPr/>
           </a:p>
         </p:txBody>
       </p:sp>
@@ -10245,6 +10142,7 @@
           <a:lstStyle/>
           <a:p>
             <a:pPr algn="ctr"/>
+            <a:endParaRPr/>
           </a:p>
         </p:txBody>
       </p:sp>
@@ -10521,7 +10419,7 @@
 </file>
 
 <file path=ppt/slides/slide4.xml><?xml version="1.0" encoding="utf-8"?>
-<p:sld xmlns:a="http://schemas.openxmlformats.org/drawingml/2006/main" xmlns:p="http://schemas.openxmlformats.org/presentationml/2006/main" xmlns:r="http://schemas.openxmlformats.org/officeDocument/2006/relationships">
+<p:sld xmlns:a="http://schemas.openxmlformats.org/drawingml/2006/main" xmlns:r="http://schemas.openxmlformats.org/officeDocument/2006/relationships" xmlns:p="http://schemas.openxmlformats.org/presentationml/2006/main">
   <p:cSld>
     <p:spTree>
       <p:nvGrpSpPr>
@@ -10529,7 +10427,14 @@
         <p:cNvGrpSpPr/>
         <p:nvPr/>
       </p:nvGrpSpPr>
-      <p:grpSpPr/>
+      <p:grpSpPr>
+        <a:xfrm>
+          <a:off x="0" y="0"/>
+          <a:ext cx="0" cy="0"/>
+          <a:chOff x="0" y="0"/>
+          <a:chExt cx="0" cy="0"/>
+        </a:xfrm>
+      </p:grpSpPr>
       <p:sp>
         <p:nvSpPr>
           <p:cNvPr id="2" name="Rectangle 1"/>
@@ -10570,6 +10475,7 @@
           <a:lstStyle/>
           <a:p>
             <a:pPr algn="ctr"/>
+            <a:endParaRPr/>
           </a:p>
         </p:txBody>
       </p:sp>
@@ -10613,6 +10519,7 @@
           <a:lstStyle/>
           <a:p>
             <a:pPr algn="ctr"/>
+            <a:endParaRPr/>
           </a:p>
         </p:txBody>
       </p:sp>
@@ -10666,8 +10573,8 @@
         </p:blipFill>
         <p:spPr>
           <a:xfrm>
-            <a:off x="457200" y="1097280"/>
-            <a:ext cx="11430000" cy="5064159"/>
+            <a:off x="457200" y="1034080"/>
+            <a:ext cx="11430000" cy="5201319"/>
           </a:xfrm>
           <a:prstGeom prst="rect">
             <a:avLst/>
@@ -10682,7 +10589,7 @@
         </p:nvSpPr>
         <p:spPr>
           <a:xfrm>
-            <a:off x="640080" y="4937760"/>
+            <a:off x="640080" y="6080760"/>
             <a:ext cx="10972800" cy="1371600"/>
           </a:xfrm>
           <a:prstGeom prst="rect">
@@ -10698,7 +10605,7 @@
           <a:p>
             <a:pPr algn="l"/>
             <a:r>
-              <a:rPr sz="1700" b="0" i="0">
+              <a:rPr sz="1700" b="0" i="0" dirty="0">
                 <a:solidFill>
                   <a:srgbClr val="1F2A44"/>
                 </a:solidFill>
@@ -10751,7 +10658,7 @@
 </file>
 
 <file path=ppt/slides/slide5.xml><?xml version="1.0" encoding="utf-8"?>
-<p:sld xmlns:a="http://schemas.openxmlformats.org/drawingml/2006/main" xmlns:p="http://schemas.openxmlformats.org/presentationml/2006/main" xmlns:r="http://schemas.openxmlformats.org/officeDocument/2006/relationships">
+<p:sld xmlns:a="http://schemas.openxmlformats.org/drawingml/2006/main" xmlns:r="http://schemas.openxmlformats.org/officeDocument/2006/relationships" xmlns:p="http://schemas.openxmlformats.org/presentationml/2006/main">
   <p:cSld>
     <p:spTree>
       <p:nvGrpSpPr>
@@ -10759,7 +10666,14 @@
         <p:cNvGrpSpPr/>
         <p:nvPr/>
       </p:nvGrpSpPr>
-      <p:grpSpPr/>
+      <p:grpSpPr>
+        <a:xfrm>
+          <a:off x="0" y="0"/>
+          <a:ext cx="0" cy="0"/>
+          <a:chOff x="0" y="0"/>
+          <a:chExt cx="0" cy="0"/>
+        </a:xfrm>
+      </p:grpSpPr>
       <p:sp>
         <p:nvSpPr>
           <p:cNvPr id="2" name="Rectangle 1"/>
@@ -10800,6 +10714,7 @@
           <a:lstStyle/>
           <a:p>
             <a:pPr algn="ctr"/>
+            <a:endParaRPr/>
           </a:p>
         </p:txBody>
       </p:sp>
@@ -10843,6 +10758,7 @@
           <a:lstStyle/>
           <a:p>
             <a:pPr algn="ctr"/>
+            <a:endParaRPr/>
           </a:p>
         </p:txBody>
       </p:sp>
@@ -10912,8 +10828,8 @@
         </p:nvSpPr>
         <p:spPr>
           <a:xfrm>
-            <a:off x="640080" y="5852160"/>
-            <a:ext cx="10972800" cy="822960"/>
+            <a:off x="518007" y="6336792"/>
+            <a:ext cx="11155680" cy="230832"/>
           </a:xfrm>
           <a:prstGeom prst="rect">
             <a:avLst/>
@@ -10928,12 +10844,60 @@
           <a:p>
             <a:pPr algn="l"/>
             <a:r>
-              <a:rPr sz="1500" b="0" i="0">
+              <a:rPr sz="1200" b="0" i="0" dirty="0">
                 <a:solidFill>
                   <a:srgbClr val="1F2A44"/>
                 </a:solidFill>
               </a:rPr>
-              <a:t>Spec requires &gt;= 2 distributed stages. This project has 3: S3 (cloud storage), EMR PySpark (distributed compute), FastAPI on EC2 + Streamlit Cloud (cloud serving).</a:t>
+              <a:t>Spec requires &gt;= 2 distributed stages. This project has 3: S3 (cloud storage), EMR </a:t>
+            </a:r>
+            <a:r>
+              <a:rPr sz="1200" b="0" i="0" dirty="0" err="1">
+                <a:solidFill>
+                  <a:srgbClr val="1F2A44"/>
+                </a:solidFill>
+              </a:rPr>
+              <a:t>PySpark</a:t>
+            </a:r>
+            <a:r>
+              <a:rPr sz="1200" b="0" i="0" dirty="0">
+                <a:solidFill>
+                  <a:srgbClr val="1F2A44"/>
+                </a:solidFill>
+              </a:rPr>
+              <a:t> (distributed compute), </a:t>
+            </a:r>
+            <a:r>
+              <a:rPr sz="1200" b="0" i="0" dirty="0" err="1">
+                <a:solidFill>
+                  <a:srgbClr val="1F2A44"/>
+                </a:solidFill>
+              </a:rPr>
+              <a:t>FastAPI</a:t>
+            </a:r>
+            <a:r>
+              <a:rPr sz="1200" b="0" i="0" dirty="0">
+                <a:solidFill>
+                  <a:srgbClr val="1F2A44"/>
+                </a:solidFill>
+              </a:rPr>
+              <a:t> on EC2 + </a:t>
+            </a:r>
+            <a:r>
+              <a:rPr sz="1200" b="0" i="0" dirty="0" err="1">
+                <a:solidFill>
+                  <a:srgbClr val="1F2A44"/>
+                </a:solidFill>
+              </a:rPr>
+              <a:t>Streamlit</a:t>
+            </a:r>
+            <a:r>
+              <a:rPr sz="1200" b="0" i="0" dirty="0">
+                <a:solidFill>
+                  <a:srgbClr val="1F2A44"/>
+                </a:solidFill>
+              </a:rPr>
+              <a:t> Cloud (cloud serving).</a:t>
             </a:r>
           </a:p>
         </p:txBody>
@@ -10981,7 +10945,7 @@
 </file>
 
 <file path=ppt/slides/slide6.xml><?xml version="1.0" encoding="utf-8"?>
-<p:sld xmlns:a="http://schemas.openxmlformats.org/drawingml/2006/main" xmlns:p="http://schemas.openxmlformats.org/presentationml/2006/main" xmlns:r="http://schemas.openxmlformats.org/officeDocument/2006/relationships">
+<p:sld xmlns:a="http://schemas.openxmlformats.org/drawingml/2006/main" xmlns:r="http://schemas.openxmlformats.org/officeDocument/2006/relationships" xmlns:p="http://schemas.openxmlformats.org/presentationml/2006/main">
   <p:cSld>
     <p:spTree>
       <p:nvGrpSpPr>
@@ -10989,7 +10953,14 @@
         <p:cNvGrpSpPr/>
         <p:nvPr/>
       </p:nvGrpSpPr>
-      <p:grpSpPr/>
+      <p:grpSpPr>
+        <a:xfrm>
+          <a:off x="0" y="0"/>
+          <a:ext cx="0" cy="0"/>
+          <a:chOff x="0" y="0"/>
+          <a:chExt cx="0" cy="0"/>
+        </a:xfrm>
+      </p:grpSpPr>
       <p:sp>
         <p:nvSpPr>
           <p:cNvPr id="2" name="Rectangle 1"/>
@@ -11030,6 +11001,7 @@
           <a:lstStyle/>
           <a:p>
             <a:pPr algn="ctr"/>
+            <a:endParaRPr/>
           </a:p>
         </p:txBody>
       </p:sp>
@@ -11073,6 +11045,7 @@
           <a:lstStyle/>
           <a:p>
             <a:pPr algn="ctr"/>
+            <a:endParaRPr/>
           </a:p>
         </p:txBody>
       </p:sp>
@@ -11211,7 +11184,7 @@
 </file>
 
 <file path=ppt/slides/slide7.xml><?xml version="1.0" encoding="utf-8"?>
-<p:sld xmlns:a="http://schemas.openxmlformats.org/drawingml/2006/main" xmlns:p="http://schemas.openxmlformats.org/presentationml/2006/main" xmlns:r="http://schemas.openxmlformats.org/officeDocument/2006/relationships">
+<p:sld xmlns:a="http://schemas.openxmlformats.org/drawingml/2006/main" xmlns:r="http://schemas.openxmlformats.org/officeDocument/2006/relationships" xmlns:p="http://schemas.openxmlformats.org/presentationml/2006/main">
   <p:cSld>
     <p:spTree>
       <p:nvGrpSpPr>
@@ -11219,7 +11192,14 @@
         <p:cNvGrpSpPr/>
         <p:nvPr/>
       </p:nvGrpSpPr>
-      <p:grpSpPr/>
+      <p:grpSpPr>
+        <a:xfrm>
+          <a:off x="0" y="0"/>
+          <a:ext cx="0" cy="0"/>
+          <a:chOff x="0" y="0"/>
+          <a:chExt cx="0" cy="0"/>
+        </a:xfrm>
+      </p:grpSpPr>
       <p:sp>
         <p:nvSpPr>
           <p:cNvPr id="2" name="Rectangle 1"/>
@@ -11260,6 +11240,7 @@
           <a:lstStyle/>
           <a:p>
             <a:pPr algn="ctr"/>
+            <a:endParaRPr/>
           </a:p>
         </p:txBody>
       </p:sp>
@@ -11303,6 +11284,7 @@
           <a:lstStyle/>
           <a:p>
             <a:pPr algn="ctr"/>
+            <a:endParaRPr/>
           </a:p>
         </p:txBody>
       </p:sp>
@@ -11381,6 +11363,7 @@
           <a:lstStyle/>
           <a:p>
             <a:pPr algn="ctr"/>
+            <a:endParaRPr/>
           </a:p>
         </p:txBody>
       </p:sp>
@@ -11495,6 +11478,7 @@
           <a:lstStyle/>
           <a:p>
             <a:pPr algn="ctr"/>
+            <a:endParaRPr/>
           </a:p>
         </p:txBody>
       </p:sp>
@@ -11611,6 +11595,7 @@
           <a:lstStyle/>
           <a:p>
             <a:pPr algn="ctr"/>
+            <a:endParaRPr/>
           </a:p>
         </p:txBody>
       </p:sp>
@@ -11762,7 +11747,7 @@
 </file>
 
 <file path=ppt/slides/slide8.xml><?xml version="1.0" encoding="utf-8"?>
-<p:sld xmlns:a="http://schemas.openxmlformats.org/drawingml/2006/main" xmlns:p="http://schemas.openxmlformats.org/presentationml/2006/main" xmlns:r="http://schemas.openxmlformats.org/officeDocument/2006/relationships">
+<p:sld xmlns:a="http://schemas.openxmlformats.org/drawingml/2006/main" xmlns:r="http://schemas.openxmlformats.org/officeDocument/2006/relationships" xmlns:p="http://schemas.openxmlformats.org/presentationml/2006/main">
   <p:cSld>
     <p:spTree>
       <p:nvGrpSpPr>
@@ -11770,7 +11755,14 @@
         <p:cNvGrpSpPr/>
         <p:nvPr/>
       </p:nvGrpSpPr>
-      <p:grpSpPr/>
+      <p:grpSpPr>
+        <a:xfrm>
+          <a:off x="0" y="0"/>
+          <a:ext cx="0" cy="0"/>
+          <a:chOff x="0" y="0"/>
+          <a:chExt cx="0" cy="0"/>
+        </a:xfrm>
+      </p:grpSpPr>
       <p:sp>
         <p:nvSpPr>
           <p:cNvPr id="2" name="Rectangle 1"/>
@@ -11811,6 +11803,7 @@
           <a:lstStyle/>
           <a:p>
             <a:pPr algn="ctr"/>
+            <a:endParaRPr/>
           </a:p>
         </p:txBody>
       </p:sp>
@@ -11854,6 +11847,7 @@
           <a:lstStyle/>
           <a:p>
             <a:pPr algn="ctr"/>
+            <a:endParaRPr/>
           </a:p>
         </p:txBody>
       </p:sp>
@@ -11907,8 +11901,8 @@
         </p:blipFill>
         <p:spPr>
           <a:xfrm>
-            <a:off x="457200" y="1097280"/>
-            <a:ext cx="11430000" cy="3905209"/>
+            <a:off x="457200" y="877824"/>
+            <a:ext cx="11430000" cy="3236977"/>
           </a:xfrm>
           <a:prstGeom prst="rect">
             <a:avLst/>
@@ -11943,7 +11937,7 @@
               </a:spcAft>
             </a:pPr>
             <a:r>
-              <a:rPr sz="1500">
+              <a:rPr sz="1500" dirty="0">
                 <a:solidFill>
                   <a:srgbClr val="1A1A1A"/>
                 </a:solidFill>
@@ -11958,7 +11952,7 @@
               </a:spcAft>
             </a:pPr>
             <a:r>
-              <a:rPr sz="1500">
+              <a:rPr sz="1500" dirty="0">
                 <a:solidFill>
                   <a:srgbClr val="1A1A1A"/>
                 </a:solidFill>
@@ -11973,6 +11967,7 @@
               </a:spcAft>
             </a:pPr>
             <a:r>
+              <a:rPr dirty="0"/>
               <a:t> </a:t>
             </a:r>
           </a:p>
@@ -11983,12 +11978,44 @@
               </a:spcAft>
             </a:pPr>
             <a:r>
-              <a:rPr sz="1500">
+              <a:rPr sz="1500" dirty="0">
                 <a:solidFill>
                   <a:srgbClr val="1A1A1A"/>
                 </a:solidFill>
               </a:rPr>
-              <a:t>Surprise constraint: gzip-compressed CSV is NOT splittable in Spark.</a:t>
+              <a:t>Surprise constraint: </a:t>
+            </a:r>
+            <a:r>
+              <a:rPr sz="1500" dirty="0" err="1">
+                <a:solidFill>
+                  <a:srgbClr val="1A1A1A"/>
+                </a:solidFill>
+              </a:rPr>
+              <a:t>gzip</a:t>
+            </a:r>
+            <a:r>
+              <a:rPr sz="1500" dirty="0">
+                <a:solidFill>
+                  <a:srgbClr val="1A1A1A"/>
+                </a:solidFill>
+              </a:rPr>
+              <a:t>-compressed CSV is NOT </a:t>
+            </a:r>
+            <a:r>
+              <a:rPr sz="1500" dirty="0" err="1">
+                <a:solidFill>
+                  <a:srgbClr val="1A1A1A"/>
+                </a:solidFill>
+              </a:rPr>
+              <a:t>splittable</a:t>
+            </a:r>
+            <a:r>
+              <a:rPr sz="1500" dirty="0">
+                <a:solidFill>
+                  <a:srgbClr val="1A1A1A"/>
+                </a:solidFill>
+              </a:rPr>
+              <a:t> in Spark.</a:t>
             </a:r>
           </a:p>
           <a:p>
@@ -11998,7 +12025,7 @@
               </a:spcAft>
             </a:pPr>
             <a:r>
-              <a:rPr sz="1500">
+              <a:rPr sz="1500" dirty="0">
                 <a:solidFill>
                   <a:srgbClr val="1A1A1A"/>
                 </a:solidFill>
@@ -12013,12 +12040,28 @@
               </a:spcAft>
             </a:pPr>
             <a:r>
-              <a:rPr sz="1500">
+              <a:rPr sz="1500" dirty="0">
                 <a:solidFill>
                   <a:srgbClr val="1A1A1A"/>
                 </a:solidFill>
               </a:rPr>
-              <a:t>sat idle through most of bronze_to_silver. In production we'd land</a:t>
+              <a:t>sat idle through most of </a:t>
+            </a:r>
+            <a:r>
+              <a:rPr sz="1500" dirty="0" err="1">
+                <a:solidFill>
+                  <a:srgbClr val="1A1A1A"/>
+                </a:solidFill>
+              </a:rPr>
+              <a:t>bronze_to_silver</a:t>
+            </a:r>
+            <a:r>
+              <a:rPr sz="1500" dirty="0">
+                <a:solidFill>
+                  <a:srgbClr val="1A1A1A"/>
+                </a:solidFill>
+              </a:rPr>
+              <a:t>. In production we'd land</a:t>
             </a:r>
           </a:p>
           <a:p>
@@ -12028,12 +12071,28 @@
               </a:spcAft>
             </a:pPr>
             <a:r>
-              <a:rPr sz="1500">
+              <a:rPr sz="1500" dirty="0">
                 <a:solidFill>
                   <a:srgbClr val="1A1A1A"/>
                 </a:solidFill>
               </a:rPr>
-              <a:t>raw .gz files as bzip2 or Snappy parquet on ingest to fix this.</a:t>
+              <a:t>raw .</a:t>
+            </a:r>
+            <a:r>
+              <a:rPr sz="1500" dirty="0" err="1">
+                <a:solidFill>
+                  <a:srgbClr val="1A1A1A"/>
+                </a:solidFill>
+              </a:rPr>
+              <a:t>gz</a:t>
+            </a:r>
+            <a:r>
+              <a:rPr sz="1500" dirty="0">
+                <a:solidFill>
+                  <a:srgbClr val="1A1A1A"/>
+                </a:solidFill>
+              </a:rPr>
+              <a:t> files as bzip2 or Snappy parquet on ingest to fix this.</a:t>
             </a:r>
           </a:p>
         </p:txBody>
@@ -12081,7 +12140,7 @@
 </file>
 
 <file path=ppt/slides/slide9.xml><?xml version="1.0" encoding="utf-8"?>
-<p:sld xmlns:a="http://schemas.openxmlformats.org/drawingml/2006/main" xmlns:p="http://schemas.openxmlformats.org/presentationml/2006/main" xmlns:r="http://schemas.openxmlformats.org/officeDocument/2006/relationships">
+<p:sld xmlns:a="http://schemas.openxmlformats.org/drawingml/2006/main" xmlns:r="http://schemas.openxmlformats.org/officeDocument/2006/relationships" xmlns:p="http://schemas.openxmlformats.org/presentationml/2006/main">
   <p:cSld>
     <p:spTree>
       <p:nvGrpSpPr>
@@ -12089,7 +12148,14 @@
         <p:cNvGrpSpPr/>
         <p:nvPr/>
       </p:nvGrpSpPr>
-      <p:grpSpPr/>
+      <p:grpSpPr>
+        <a:xfrm>
+          <a:off x="0" y="0"/>
+          <a:ext cx="0" cy="0"/>
+          <a:chOff x="0" y="0"/>
+          <a:chExt cx="0" cy="0"/>
+        </a:xfrm>
+      </p:grpSpPr>
       <p:sp>
         <p:nvSpPr>
           <p:cNvPr id="2" name="Rectangle 1"/>
@@ -12130,6 +12196,7 @@
           <a:lstStyle/>
           <a:p>
             <a:pPr algn="ctr"/>
+            <a:endParaRPr/>
           </a:p>
         </p:txBody>
       </p:sp>
@@ -12173,6 +12240,7 @@
           <a:lstStyle/>
           <a:p>
             <a:pPr algn="ctr"/>
+            <a:endParaRPr/>
           </a:p>
         </p:txBody>
       </p:sp>
@@ -12781,44 +12849,44 @@
         <a:sysClr val="window" lastClr="FFFFFF"/>
       </a:lt1>
       <a:dk2>
-        <a:srgbClr val="1F497D"/>
+        <a:srgbClr val="0E2841"/>
       </a:dk2>
       <a:lt2>
-        <a:srgbClr val="EEECE1"/>
+        <a:srgbClr val="E8E8E8"/>
       </a:lt2>
       <a:accent1>
-        <a:srgbClr val="4F81BD"/>
+        <a:srgbClr val="156082"/>
       </a:accent1>
       <a:accent2>
-        <a:srgbClr val="C0504D"/>
+        <a:srgbClr val="E97132"/>
       </a:accent2>
       <a:accent3>
-        <a:srgbClr val="9BBB59"/>
+        <a:srgbClr val="196B24"/>
       </a:accent3>
       <a:accent4>
-        <a:srgbClr val="8064A2"/>
+        <a:srgbClr val="0F9ED5"/>
       </a:accent4>
       <a:accent5>
-        <a:srgbClr val="4BACC6"/>
+        <a:srgbClr val="A02B93"/>
       </a:accent5>
       <a:accent6>
-        <a:srgbClr val="F79646"/>
+        <a:srgbClr val="4EA72E"/>
       </a:accent6>
       <a:hlink>
-        <a:srgbClr val="0000FF"/>
+        <a:srgbClr val="467886"/>
       </a:hlink>
       <a:folHlink>
-        <a:srgbClr val="800080"/>
+        <a:srgbClr val="96607D"/>
       </a:folHlink>
     </a:clrScheme>
     <a:fontScheme name="Office">
       <a:majorFont>
-        <a:latin typeface="Calibri"/>
+        <a:latin typeface="Aptos Display" panose="02110004020202020204"/>
         <a:ea typeface=""/>
         <a:cs typeface=""/>
-        <a:font script="Jpan" typeface="ＭＳ Ｐゴシック"/>
+        <a:font script="Jpan" typeface="游ゴシック Light"/>
         <a:font script="Hang" typeface="맑은 고딕"/>
-        <a:font script="Hans" typeface="宋体"/>
+        <a:font script="Hans" typeface="等线 Light"/>
         <a:font script="Hant" typeface="新細明體"/>
         <a:font script="Arab" typeface="Times New Roman"/>
         <a:font script="Hebr" typeface="Times New Roman"/>
@@ -12846,14 +12914,31 @@
         <a:font script="Viet" typeface="Times New Roman"/>
         <a:font script="Uigh" typeface="Microsoft Uighur"/>
         <a:font script="Geor" typeface="Sylfaen"/>
+        <a:font script="Armn" typeface="Arial"/>
+        <a:font script="Bugi" typeface="Leelawadee UI"/>
+        <a:font script="Bopo" typeface="Microsoft JhengHei"/>
+        <a:font script="Java" typeface="Javanese Text"/>
+        <a:font script="Lisu" typeface="Segoe UI"/>
+        <a:font script="Mymr" typeface="Myanmar Text"/>
+        <a:font script="Nkoo" typeface="Ebrima"/>
+        <a:font script="Olck" typeface="Nirmala UI"/>
+        <a:font script="Osma" typeface="Ebrima"/>
+        <a:font script="Phag" typeface="Phagspa"/>
+        <a:font script="Syrn" typeface="Estrangelo Edessa"/>
+        <a:font script="Syrj" typeface="Estrangelo Edessa"/>
+        <a:font script="Syre" typeface="Estrangelo Edessa"/>
+        <a:font script="Sora" typeface="Nirmala UI"/>
+        <a:font script="Tale" typeface="Microsoft Tai Le"/>
+        <a:font script="Talu" typeface="Microsoft New Tai Lue"/>
+        <a:font script="Tfng" typeface="Ebrima"/>
       </a:majorFont>
       <a:minorFont>
-        <a:latin typeface="Calibri"/>
+        <a:latin typeface="Aptos" panose="02110004020202020204"/>
         <a:ea typeface=""/>
         <a:cs typeface=""/>
-        <a:font script="Jpan" typeface="ＭＳ Ｐゴシック"/>
+        <a:font script="Jpan" typeface="游ゴシック"/>
         <a:font script="Hang" typeface="맑은 고딕"/>
-        <a:font script="Hans" typeface="宋体"/>
+        <a:font script="Hans" typeface="等线"/>
         <a:font script="Hant" typeface="新細明體"/>
         <a:font script="Arab" typeface="Arial"/>
         <a:font script="Hebr" typeface="Arial"/>
@@ -12881,6 +12966,23 @@
         <a:font script="Viet" typeface="Arial"/>
         <a:font script="Uigh" typeface="Microsoft Uighur"/>
         <a:font script="Geor" typeface="Sylfaen"/>
+        <a:font script="Armn" typeface="Arial"/>
+        <a:font script="Bugi" typeface="Leelawadee UI"/>
+        <a:font script="Bopo" typeface="Microsoft JhengHei"/>
+        <a:font script="Java" typeface="Javanese Text"/>
+        <a:font script="Lisu" typeface="Segoe UI"/>
+        <a:font script="Mymr" typeface="Myanmar Text"/>
+        <a:font script="Nkoo" typeface="Ebrima"/>
+        <a:font script="Olck" typeface="Nirmala UI"/>
+        <a:font script="Osma" typeface="Ebrima"/>
+        <a:font script="Phag" typeface="Phagspa"/>
+        <a:font script="Syrn" typeface="Estrangelo Edessa"/>
+        <a:font script="Syrj" typeface="Estrangelo Edessa"/>
+        <a:font script="Syre" typeface="Estrangelo Edessa"/>
+        <a:font script="Sora" typeface="Nirmala UI"/>
+        <a:font script="Tale" typeface="Microsoft Tai Le"/>
+        <a:font script="Talu" typeface="Microsoft New Tai Lue"/>
+        <a:font script="Tfng" typeface="Ebrima"/>
       </a:minorFont>
     </a:fontScheme>
     <a:fmtScheme name="Office">
@@ -12892,180 +12994,136 @@
           <a:gsLst>
             <a:gs pos="0">
               <a:schemeClr val="phClr">
-                <a:tint val="50000"/>
-                <a:satMod val="300000"/>
+                <a:lumMod val="110000"/>
+                <a:satMod val="105000"/>
+                <a:tint val="67000"/>
               </a:schemeClr>
             </a:gs>
-            <a:gs pos="35000">
+            <a:gs pos="50000">
               <a:schemeClr val="phClr">
-                <a:tint val="37000"/>
-                <a:satMod val="300000"/>
+                <a:lumMod val="105000"/>
+                <a:satMod val="103000"/>
+                <a:tint val="73000"/>
               </a:schemeClr>
             </a:gs>
             <a:gs pos="100000">
               <a:schemeClr val="phClr">
-                <a:tint val="15000"/>
-                <a:satMod val="350000"/>
+                <a:lumMod val="105000"/>
+                <a:satMod val="109000"/>
+                <a:tint val="81000"/>
               </a:schemeClr>
             </a:gs>
           </a:gsLst>
-          <a:lin ang="16200000" scaled="1"/>
+          <a:lin ang="5400000" scaled="0"/>
         </a:gradFill>
         <a:gradFill rotWithShape="1">
           <a:gsLst>
             <a:gs pos="0">
               <a:schemeClr val="phClr">
-                <a:tint val="100000"/>
+                <a:satMod val="103000"/>
+                <a:lumMod val="102000"/>
+                <a:tint val="94000"/>
+              </a:schemeClr>
+            </a:gs>
+            <a:gs pos="50000">
+              <a:schemeClr val="phClr">
+                <a:satMod val="110000"/>
+                <a:lumMod val="100000"/>
                 <a:shade val="100000"/>
-                <a:satMod val="130000"/>
               </a:schemeClr>
             </a:gs>
             <a:gs pos="100000">
               <a:schemeClr val="phClr">
-                <a:tint val="50000"/>
-                <a:shade val="100000"/>
-                <a:satMod val="350000"/>
+                <a:lumMod val="99000"/>
+                <a:satMod val="120000"/>
+                <a:shade val="78000"/>
               </a:schemeClr>
             </a:gs>
           </a:gsLst>
-          <a:lin ang="16200000" scaled="0"/>
+          <a:lin ang="5400000" scaled="0"/>
         </a:gradFill>
       </a:fillStyleLst>
       <a:lnStyleLst>
-        <a:ln w="9525" cap="flat" cmpd="sng" algn="ctr">
+        <a:ln w="12700" cap="flat" cmpd="sng" algn="ctr">
           <a:solidFill>
-            <a:schemeClr val="phClr">
-              <a:shade val="95000"/>
-              <a:satMod val="105000"/>
-            </a:schemeClr>
+            <a:schemeClr val="phClr"/>
           </a:solidFill>
           <a:prstDash val="solid"/>
+          <a:miter lim="800000"/>
+        </a:ln>
+        <a:ln w="19050" cap="flat" cmpd="sng" algn="ctr">
+          <a:solidFill>
+            <a:schemeClr val="phClr"/>
+          </a:solidFill>
+          <a:prstDash val="solid"/>
+          <a:miter lim="800000"/>
         </a:ln>
         <a:ln w="25400" cap="flat" cmpd="sng" algn="ctr">
           <a:solidFill>
             <a:schemeClr val="phClr"/>
           </a:solidFill>
           <a:prstDash val="solid"/>
-        </a:ln>
-        <a:ln w="38100" cap="flat" cmpd="sng" algn="ctr">
-          <a:solidFill>
-            <a:schemeClr val="phClr"/>
-          </a:solidFill>
-          <a:prstDash val="solid"/>
+          <a:miter lim="800000"/>
         </a:ln>
       </a:lnStyleLst>
       <a:effectStyleLst>
         <a:effectStyle>
+          <a:effectLst/>
+        </a:effectStyle>
+        <a:effectStyle>
+          <a:effectLst/>
+        </a:effectStyle>
+        <a:effectStyle>
           <a:effectLst>
-            <a:outerShdw blurRad="40000" dist="20000" dir="5400000" rotWithShape="0">
+            <a:outerShdw blurRad="57150" dist="19050" dir="5400000" algn="ctr" rotWithShape="0">
               <a:srgbClr val="000000">
-                <a:alpha val="38000"/>
+                <a:alpha val="63000"/>
               </a:srgbClr>
             </a:outerShdw>
           </a:effectLst>
-        </a:effectStyle>
-        <a:effectStyle>
-          <a:effectLst>
-            <a:outerShdw blurRad="40000" dist="23000" dir="5400000" rotWithShape="0">
-              <a:srgbClr val="000000">
-                <a:alpha val="35000"/>
-              </a:srgbClr>
-            </a:outerShdw>
-          </a:effectLst>
-        </a:effectStyle>
-        <a:effectStyle>
-          <a:effectLst>
-            <a:outerShdw blurRad="40000" dist="23000" dir="5400000" rotWithShape="0">
-              <a:srgbClr val="000000">
-                <a:alpha val="35000"/>
-              </a:srgbClr>
-            </a:outerShdw>
-          </a:effectLst>
-          <a:scene3d>
-            <a:camera prst="orthographicFront">
-              <a:rot lat="0" lon="0" rev="0"/>
-            </a:camera>
-            <a:lightRig rig="threePt" dir="t">
-              <a:rot lat="0" lon="0" rev="1200000"/>
-            </a:lightRig>
-          </a:scene3d>
-          <a:sp3d>
-            <a:bevelT w="63500" h="25400"/>
-          </a:sp3d>
         </a:effectStyle>
       </a:effectStyleLst>
       <a:bgFillStyleLst>
         <a:solidFill>
           <a:schemeClr val="phClr"/>
         </a:solidFill>
+        <a:solidFill>
+          <a:schemeClr val="phClr">
+            <a:tint val="95000"/>
+            <a:satMod val="170000"/>
+          </a:schemeClr>
+        </a:solidFill>
         <a:gradFill rotWithShape="1">
           <a:gsLst>
             <a:gs pos="0">
               <a:schemeClr val="phClr">
-                <a:tint val="40000"/>
-                <a:satMod val="350000"/>
+                <a:tint val="93000"/>
+                <a:satMod val="150000"/>
+                <a:shade val="98000"/>
+                <a:lumMod val="102000"/>
               </a:schemeClr>
             </a:gs>
-            <a:gs pos="40000">
+            <a:gs pos="50000">
               <a:schemeClr val="phClr">
-                <a:tint val="45000"/>
-                <a:shade val="99000"/>
-                <a:satMod val="350000"/>
+                <a:tint val="98000"/>
+                <a:satMod val="130000"/>
+                <a:shade val="90000"/>
+                <a:lumMod val="103000"/>
               </a:schemeClr>
             </a:gs>
             <a:gs pos="100000">
               <a:schemeClr val="phClr">
-                <a:shade val="20000"/>
-                <a:satMod val="255000"/>
+                <a:shade val="63000"/>
+                <a:satMod val="120000"/>
               </a:schemeClr>
             </a:gs>
           </a:gsLst>
-          <a:path path="circle">
-            <a:fillToRect l="50000" t="-80000" r="50000" b="180000"/>
-          </a:path>
-        </a:gradFill>
-        <a:gradFill rotWithShape="1">
-          <a:gsLst>
-            <a:gs pos="0">
-              <a:schemeClr val="phClr">
-                <a:tint val="80000"/>
-                <a:satMod val="300000"/>
-              </a:schemeClr>
-            </a:gs>
-            <a:gs pos="100000">
-              <a:schemeClr val="phClr">
-                <a:shade val="30000"/>
-                <a:satMod val="200000"/>
-              </a:schemeClr>
-            </a:gs>
-          </a:gsLst>
-          <a:path path="circle">
-            <a:fillToRect l="50000" t="50000" r="50000" b="50000"/>
-          </a:path>
+          <a:lin ang="5400000" scaled="0"/>
         </a:gradFill>
       </a:bgFillStyleLst>
     </a:fmtScheme>
   </a:themeElements>
   <a:objectDefaults>
-    <a:spDef>
-      <a:spPr/>
-      <a:bodyPr/>
-      <a:lstStyle/>
-      <a:style>
-        <a:lnRef idx="1">
-          <a:schemeClr val="accent1"/>
-        </a:lnRef>
-        <a:fillRef idx="3">
-          <a:schemeClr val="accent1"/>
-        </a:fillRef>
-        <a:effectRef idx="2">
-          <a:schemeClr val="accent1"/>
-        </a:effectRef>
-        <a:fontRef idx="minor">
-          <a:schemeClr val="lt1"/>
-        </a:fontRef>
-      </a:style>
-    </a:spDef>
     <a:lnDef>
       <a:spPr/>
       <a:bodyPr/>
@@ -13087,5 +13145,10 @@
     </a:lnDef>
   </a:objectDefaults>
   <a:extraClrSchemeLst/>
+  <a:extLst>
+    <a:ext uri="{05A4C25C-085E-4340-85A3-A5531E510DB2}">
+      <thm15:themeFamily xmlns:thm15="http://schemas.microsoft.com/office/thememl/2012/main" name="Office Theme" id="{2E142A2C-CD16-42D6-873A-C26D2A0506FA}" vid="{1BDDFF52-6CD6-40A5-AB3C-68EB2F1E4D0A}"/>
+    </a:ext>
+  </a:extLst>
 </a:theme>
 </file>
</xml_diff>